<commit_message>
feat: Brevo transactional email notifications for registration and events
</commit_message>
<xml_diff>
--- a/CampusCircle_Presentation.pptx
+++ b/CampusCircle_Presentation.pptx
@@ -1,25 +1,37 @@
 
 <file path=ppt/presentation.xml><?xml version="1.0" encoding="utf-8"?>
-<p:presentation xmlns:a="http://schemas.openxmlformats.org/drawingml/2006/main" xmlns:r="http://schemas.openxmlformats.org/officeDocument/2006/relationships" xmlns:p="http://schemas.openxmlformats.org/presentationml/2006/main" saveSubsetFonts="1" autoCompressPictures="0">
+<p:presentation xmlns:a="http://schemas.openxmlformats.org/drawingml/2006/main" xmlns:r="http://schemas.openxmlformats.org/officeDocument/2006/relationships" xmlns:p="http://schemas.openxmlformats.org/presentationml/2006/main" embedTrueTypeFonts="1" saveSubsetFonts="1" autoCompressPictures="0">
   <p:sldMasterIdLst>
     <p:sldMasterId id="2147483648" r:id="rId1"/>
   </p:sldMasterIdLst>
   <p:sldIdLst>
-    <p:sldId id="256" r:id="rId7"/>
-    <p:sldId id="257" r:id="rId8"/>
-    <p:sldId id="258" r:id="rId9"/>
-    <p:sldId id="259" r:id="rId10"/>
-    <p:sldId id="260" r:id="rId11"/>
-    <p:sldId id="261" r:id="rId12"/>
-    <p:sldId id="262" r:id="rId13"/>
-    <p:sldId id="263" r:id="rId14"/>
-    <p:sldId id="264" r:id="rId15"/>
-    <p:sldId id="265" r:id="rId16"/>
-    <p:sldId id="266" r:id="rId17"/>
-    <p:sldId id="267" r:id="rId18"/>
+    <p:sldId id="256" r:id="rId2"/>
+    <p:sldId id="257" r:id="rId11"/>
+    <p:sldId id="258" r:id="rId12"/>
+    <p:sldId id="259" r:id="rId13"/>
+    <p:sldId id="260" r:id="rId14"/>
+    <p:sldId id="261" r:id="rId15"/>
+    <p:sldId id="262" r:id="rId16"/>
+    <p:sldId id="263" r:id="rId17"/>
+    <p:sldId id="264" r:id="rId18"/>
+    <p:sldId id="265" r:id="rId19"/>
+    <p:sldId id="266" r:id="rId20"/>
+    <p:sldId id="267" r:id="rId21"/>
   </p:sldIdLst>
-  <p:sldSz cx="12188952" cy="6858000" type="screen4x3"/>
+  <p:sldSz cx="12192000" cy="6858000"/>
   <p:notesSz cx="6858000" cy="9144000"/>
+  <p:embeddedFontLst>
+    <p:embeddedFont>
+      <p:font typeface="Montserrat" panose="00000500000000000000" pitchFamily="2" charset="0"/>
+      <p:regular r:id="rId3"/>
+      <p:bold r:id="rId4"/>
+    </p:embeddedFont>
+    <p:embeddedFont>
+      <p:font typeface="Poppins" panose="00000500000000000000" pitchFamily="2" charset="0"/>
+      <p:regular r:id="rId5"/>
+      <p:bold r:id="rId6"/>
+    </p:embeddedFont>
+  </p:embeddedFontLst>
   <p:defaultTextStyle>
     <a:defPPr>
       <a:defRPr lang="en-US"/>
@@ -115,6 +127,22 @@
       </a:defRPr>
     </a:lvl9pPr>
   </p:defaultTextStyle>
+  <p:extLst>
+    <p:ext uri="{EFAFB233-063F-42B5-8137-9DF3F51BA10A}">
+      <p15:sldGuideLst xmlns:p15="http://schemas.microsoft.com/office/powerpoint/2012/main">
+        <p15:guide id="1" orient="horz" pos="2160">
+          <p15:clr>
+            <a:srgbClr val="A4A3A4"/>
+          </p15:clr>
+        </p15:guide>
+        <p15:guide id="2" pos="2880">
+          <p15:clr>
+            <a:srgbClr val="A4A3A4"/>
+          </p15:clr>
+        </p15:guide>
+      </p15:sldGuideLst>
+    </p:ext>
+  </p:extLst>
 </p:presentation>
 </file>
 
@@ -156,10 +184,9 @@
           <a:lstStyle/>
           <a:p>
             <a:r>
-              <a:rPr lang="en-US" smtClean="0"/>
+              <a:rPr lang="en-US"/>
               <a:t>Click to edit Master title style</a:t>
             </a:r>
-            <a:endParaRPr lang="en-US"/>
           </a:p>
         </p:txBody>
       </p:sp>
@@ -275,10 +302,9 @@
           </a:lstStyle>
           <a:p>
             <a:r>
-              <a:rPr lang="en-US" smtClean="0"/>
+              <a:rPr lang="en-US"/>
               <a:t>Click to edit Master subtitle style</a:t>
             </a:r>
-            <a:endParaRPr lang="en-US"/>
           </a:p>
         </p:txBody>
       </p:sp>
@@ -299,7 +325,7 @@
           <a:p>
             <a:fld id="{5BCAD085-E8A6-8845-BD4E-CB4CCA059FC4}" type="datetimeFigureOut">
               <a:rPr lang="en-US" smtClean="0"/>
-              <a:t>1/27/13</a:t>
+              <a:t>10/23/2026</a:t>
             </a:fld>
             <a:endParaRPr lang="en-US"/>
           </a:p>
@@ -393,10 +419,9 @@
           <a:lstStyle/>
           <a:p>
             <a:r>
-              <a:rPr lang="en-US" smtClean="0"/>
+              <a:rPr lang="en-US"/>
               <a:t>Click to edit Master title style</a:t>
             </a:r>
-            <a:endParaRPr lang="en-US"/>
           </a:p>
         </p:txBody>
       </p:sp>
@@ -417,38 +442,37 @@
           <a:p>
             <a:pPr lvl="0"/>
             <a:r>
-              <a:rPr lang="en-US" smtClean="0"/>
+              <a:rPr lang="en-US"/>
               <a:t>Click to edit Master text styles</a:t>
             </a:r>
           </a:p>
           <a:p>
             <a:pPr lvl="1"/>
             <a:r>
-              <a:rPr lang="en-US" smtClean="0"/>
+              <a:rPr lang="en-US"/>
               <a:t>Second level</a:t>
             </a:r>
           </a:p>
           <a:p>
             <a:pPr lvl="2"/>
             <a:r>
-              <a:rPr lang="en-US" smtClean="0"/>
+              <a:rPr lang="en-US"/>
               <a:t>Third level</a:t>
             </a:r>
           </a:p>
           <a:p>
             <a:pPr lvl="3"/>
             <a:r>
-              <a:rPr lang="en-US" smtClean="0"/>
+              <a:rPr lang="en-US"/>
               <a:t>Fourth level</a:t>
             </a:r>
           </a:p>
           <a:p>
             <a:pPr lvl="4"/>
             <a:r>
-              <a:rPr lang="en-US" smtClean="0"/>
+              <a:rPr lang="en-US"/>
               <a:t>Fifth level</a:t>
             </a:r>
-            <a:endParaRPr lang="en-US"/>
           </a:p>
         </p:txBody>
       </p:sp>
@@ -469,7 +493,7 @@
           <a:p>
             <a:fld id="{5BCAD085-E8A6-8845-BD4E-CB4CCA059FC4}" type="datetimeFigureOut">
               <a:rPr lang="en-US" smtClean="0"/>
-              <a:t>1/27/13</a:t>
+              <a:t>10/23/2026</a:t>
             </a:fld>
             <a:endParaRPr lang="en-US"/>
           </a:p>
@@ -568,10 +592,9 @@
           <a:lstStyle/>
           <a:p>
             <a:r>
-              <a:rPr lang="en-US" smtClean="0"/>
+              <a:rPr lang="en-US"/>
               <a:t>Click to edit Master title style</a:t>
             </a:r>
-            <a:endParaRPr lang="en-US"/>
           </a:p>
         </p:txBody>
       </p:sp>
@@ -597,38 +620,37 @@
           <a:p>
             <a:pPr lvl="0"/>
             <a:r>
-              <a:rPr lang="en-US" smtClean="0"/>
+              <a:rPr lang="en-US"/>
               <a:t>Click to edit Master text styles</a:t>
             </a:r>
           </a:p>
           <a:p>
             <a:pPr lvl="1"/>
             <a:r>
-              <a:rPr lang="en-US" smtClean="0"/>
+              <a:rPr lang="en-US"/>
               <a:t>Second level</a:t>
             </a:r>
           </a:p>
           <a:p>
             <a:pPr lvl="2"/>
             <a:r>
-              <a:rPr lang="en-US" smtClean="0"/>
+              <a:rPr lang="en-US"/>
               <a:t>Third level</a:t>
             </a:r>
           </a:p>
           <a:p>
             <a:pPr lvl="3"/>
             <a:r>
-              <a:rPr lang="en-US" smtClean="0"/>
+              <a:rPr lang="en-US"/>
               <a:t>Fourth level</a:t>
             </a:r>
           </a:p>
           <a:p>
             <a:pPr lvl="4"/>
             <a:r>
-              <a:rPr lang="en-US" smtClean="0"/>
+              <a:rPr lang="en-US"/>
               <a:t>Fifth level</a:t>
             </a:r>
-            <a:endParaRPr lang="en-US"/>
           </a:p>
         </p:txBody>
       </p:sp>
@@ -649,7 +671,7 @@
           <a:p>
             <a:fld id="{5BCAD085-E8A6-8845-BD4E-CB4CCA059FC4}" type="datetimeFigureOut">
               <a:rPr lang="en-US" smtClean="0"/>
-              <a:t>1/27/13</a:t>
+              <a:t>10/23/2026</a:t>
             </a:fld>
             <a:endParaRPr lang="en-US"/>
           </a:p>
@@ -743,10 +765,9 @@
           <a:lstStyle/>
           <a:p>
             <a:r>
-              <a:rPr lang="en-US" smtClean="0"/>
+              <a:rPr lang="en-US"/>
               <a:t>Click to edit Master title style</a:t>
             </a:r>
-            <a:endParaRPr lang="en-US"/>
           </a:p>
         </p:txBody>
       </p:sp>
@@ -767,38 +788,37 @@
           <a:p>
             <a:pPr lvl="0"/>
             <a:r>
-              <a:rPr lang="en-US" smtClean="0"/>
+              <a:rPr lang="en-US"/>
               <a:t>Click to edit Master text styles</a:t>
             </a:r>
           </a:p>
           <a:p>
             <a:pPr lvl="1"/>
             <a:r>
-              <a:rPr lang="en-US" smtClean="0"/>
+              <a:rPr lang="en-US"/>
               <a:t>Second level</a:t>
             </a:r>
           </a:p>
           <a:p>
             <a:pPr lvl="2"/>
             <a:r>
-              <a:rPr lang="en-US" smtClean="0"/>
+              <a:rPr lang="en-US"/>
               <a:t>Third level</a:t>
             </a:r>
           </a:p>
           <a:p>
             <a:pPr lvl="3"/>
             <a:r>
-              <a:rPr lang="en-US" smtClean="0"/>
+              <a:rPr lang="en-US"/>
               <a:t>Fourth level</a:t>
             </a:r>
           </a:p>
           <a:p>
             <a:pPr lvl="4"/>
             <a:r>
-              <a:rPr lang="en-US" smtClean="0"/>
+              <a:rPr lang="en-US"/>
               <a:t>Fifth level</a:t>
             </a:r>
-            <a:endParaRPr lang="en-US"/>
           </a:p>
         </p:txBody>
       </p:sp>
@@ -819,7 +839,7 @@
           <a:p>
             <a:fld id="{5BCAD085-E8A6-8845-BD4E-CB4CCA059FC4}" type="datetimeFigureOut">
               <a:rPr lang="en-US" smtClean="0"/>
-              <a:t>1/27/13</a:t>
+              <a:t>10/23/2026</a:t>
             </a:fld>
             <a:endParaRPr lang="en-US"/>
           </a:p>
@@ -922,10 +942,9 @@
           </a:lstStyle>
           <a:p>
             <a:r>
-              <a:rPr lang="en-US" smtClean="0"/>
+              <a:rPr lang="en-US"/>
               <a:t>Click to edit Master title style</a:t>
             </a:r>
-            <a:endParaRPr lang="en-US"/>
           </a:p>
         </p:txBody>
       </p:sp>
@@ -1042,7 +1061,7 @@
           <a:p>
             <a:pPr lvl="0"/>
             <a:r>
-              <a:rPr lang="en-US" smtClean="0"/>
+              <a:rPr lang="en-US"/>
               <a:t>Click to edit Master text styles</a:t>
             </a:r>
           </a:p>
@@ -1065,7 +1084,7 @@
           <a:p>
             <a:fld id="{5BCAD085-E8A6-8845-BD4E-CB4CCA059FC4}" type="datetimeFigureOut">
               <a:rPr lang="en-US" smtClean="0"/>
-              <a:t>1/27/13</a:t>
+              <a:t>10/23/2026</a:t>
             </a:fld>
             <a:endParaRPr lang="en-US"/>
           </a:p>
@@ -1159,10 +1178,9 @@
           <a:lstStyle/>
           <a:p>
             <a:r>
-              <a:rPr lang="en-US" smtClean="0"/>
+              <a:rPr lang="en-US"/>
               <a:t>Click to edit Master title style</a:t>
             </a:r>
-            <a:endParaRPr lang="en-US"/>
           </a:p>
         </p:txBody>
       </p:sp>
@@ -1216,38 +1234,37 @@
           <a:p>
             <a:pPr lvl="0"/>
             <a:r>
-              <a:rPr lang="en-US" smtClean="0"/>
+              <a:rPr lang="en-US"/>
               <a:t>Click to edit Master text styles</a:t>
             </a:r>
           </a:p>
           <a:p>
             <a:pPr lvl="1"/>
             <a:r>
-              <a:rPr lang="en-US" smtClean="0"/>
+              <a:rPr lang="en-US"/>
               <a:t>Second level</a:t>
             </a:r>
           </a:p>
           <a:p>
             <a:pPr lvl="2"/>
             <a:r>
-              <a:rPr lang="en-US" smtClean="0"/>
+              <a:rPr lang="en-US"/>
               <a:t>Third level</a:t>
             </a:r>
           </a:p>
           <a:p>
             <a:pPr lvl="3"/>
             <a:r>
-              <a:rPr lang="en-US" smtClean="0"/>
+              <a:rPr lang="en-US"/>
               <a:t>Fourth level</a:t>
             </a:r>
           </a:p>
           <a:p>
             <a:pPr lvl="4"/>
             <a:r>
-              <a:rPr lang="en-US" smtClean="0"/>
+              <a:rPr lang="en-US"/>
               <a:t>Fifth level</a:t>
             </a:r>
-            <a:endParaRPr lang="en-US"/>
           </a:p>
         </p:txBody>
       </p:sp>
@@ -1301,38 +1318,37 @@
           <a:p>
             <a:pPr lvl="0"/>
             <a:r>
-              <a:rPr lang="en-US" smtClean="0"/>
+              <a:rPr lang="en-US"/>
               <a:t>Click to edit Master text styles</a:t>
             </a:r>
           </a:p>
           <a:p>
             <a:pPr lvl="1"/>
             <a:r>
-              <a:rPr lang="en-US" smtClean="0"/>
+              <a:rPr lang="en-US"/>
               <a:t>Second level</a:t>
             </a:r>
           </a:p>
           <a:p>
             <a:pPr lvl="2"/>
             <a:r>
-              <a:rPr lang="en-US" smtClean="0"/>
+              <a:rPr lang="en-US"/>
               <a:t>Third level</a:t>
             </a:r>
           </a:p>
           <a:p>
             <a:pPr lvl="3"/>
             <a:r>
-              <a:rPr lang="en-US" smtClean="0"/>
+              <a:rPr lang="en-US"/>
               <a:t>Fourth level</a:t>
             </a:r>
           </a:p>
           <a:p>
             <a:pPr lvl="4"/>
             <a:r>
-              <a:rPr lang="en-US" smtClean="0"/>
+              <a:rPr lang="en-US"/>
               <a:t>Fifth level</a:t>
             </a:r>
-            <a:endParaRPr lang="en-US"/>
           </a:p>
         </p:txBody>
       </p:sp>
@@ -1353,7 +1369,7 @@
           <a:p>
             <a:fld id="{5BCAD085-E8A6-8845-BD4E-CB4CCA059FC4}" type="datetimeFigureOut">
               <a:rPr lang="en-US" smtClean="0"/>
-              <a:t>1/27/13</a:t>
+              <a:t>10/23/2026</a:t>
             </a:fld>
             <a:endParaRPr lang="en-US"/>
           </a:p>
@@ -1451,10 +1467,9 @@
           </a:lstStyle>
           <a:p>
             <a:r>
-              <a:rPr lang="en-US" smtClean="0"/>
+              <a:rPr lang="en-US"/>
               <a:t>Click to edit Master title style</a:t>
             </a:r>
-            <a:endParaRPr lang="en-US"/>
           </a:p>
         </p:txBody>
       </p:sp>
@@ -1517,7 +1532,7 @@
           <a:p>
             <a:pPr lvl="0"/>
             <a:r>
-              <a:rPr lang="en-US" smtClean="0"/>
+              <a:rPr lang="en-US"/>
               <a:t>Click to edit Master text styles</a:t>
             </a:r>
           </a:p>
@@ -1573,38 +1588,37 @@
           <a:p>
             <a:pPr lvl="0"/>
             <a:r>
-              <a:rPr lang="en-US" smtClean="0"/>
+              <a:rPr lang="en-US"/>
               <a:t>Click to edit Master text styles</a:t>
             </a:r>
           </a:p>
           <a:p>
             <a:pPr lvl="1"/>
             <a:r>
-              <a:rPr lang="en-US" smtClean="0"/>
+              <a:rPr lang="en-US"/>
               <a:t>Second level</a:t>
             </a:r>
           </a:p>
           <a:p>
             <a:pPr lvl="2"/>
             <a:r>
-              <a:rPr lang="en-US" smtClean="0"/>
+              <a:rPr lang="en-US"/>
               <a:t>Third level</a:t>
             </a:r>
           </a:p>
           <a:p>
             <a:pPr lvl="3"/>
             <a:r>
-              <a:rPr lang="en-US" smtClean="0"/>
+              <a:rPr lang="en-US"/>
               <a:t>Fourth level</a:t>
             </a:r>
           </a:p>
           <a:p>
             <a:pPr lvl="4"/>
             <a:r>
-              <a:rPr lang="en-US" smtClean="0"/>
+              <a:rPr lang="en-US"/>
               <a:t>Fifth level</a:t>
             </a:r>
-            <a:endParaRPr lang="en-US"/>
           </a:p>
         </p:txBody>
       </p:sp>
@@ -1667,7 +1681,7 @@
           <a:p>
             <a:pPr lvl="0"/>
             <a:r>
-              <a:rPr lang="en-US" smtClean="0"/>
+              <a:rPr lang="en-US"/>
               <a:t>Click to edit Master text styles</a:t>
             </a:r>
           </a:p>
@@ -1723,38 +1737,37 @@
           <a:p>
             <a:pPr lvl="0"/>
             <a:r>
-              <a:rPr lang="en-US" smtClean="0"/>
+              <a:rPr lang="en-US"/>
               <a:t>Click to edit Master text styles</a:t>
             </a:r>
           </a:p>
           <a:p>
             <a:pPr lvl="1"/>
             <a:r>
-              <a:rPr lang="en-US" smtClean="0"/>
+              <a:rPr lang="en-US"/>
               <a:t>Second level</a:t>
             </a:r>
           </a:p>
           <a:p>
             <a:pPr lvl="2"/>
             <a:r>
-              <a:rPr lang="en-US" smtClean="0"/>
+              <a:rPr lang="en-US"/>
               <a:t>Third level</a:t>
             </a:r>
           </a:p>
           <a:p>
             <a:pPr lvl="3"/>
             <a:r>
-              <a:rPr lang="en-US" smtClean="0"/>
+              <a:rPr lang="en-US"/>
               <a:t>Fourth level</a:t>
             </a:r>
           </a:p>
           <a:p>
             <a:pPr lvl="4"/>
             <a:r>
-              <a:rPr lang="en-US" smtClean="0"/>
+              <a:rPr lang="en-US"/>
               <a:t>Fifth level</a:t>
             </a:r>
-            <a:endParaRPr lang="en-US"/>
           </a:p>
         </p:txBody>
       </p:sp>
@@ -1775,7 +1788,7 @@
           <a:p>
             <a:fld id="{5BCAD085-E8A6-8845-BD4E-CB4CCA059FC4}" type="datetimeFigureOut">
               <a:rPr lang="en-US" smtClean="0"/>
-              <a:t>1/27/13</a:t>
+              <a:t>10/23/2026</a:t>
             </a:fld>
             <a:endParaRPr lang="en-US"/>
           </a:p>
@@ -1869,10 +1882,9 @@
           <a:lstStyle/>
           <a:p>
             <a:r>
-              <a:rPr lang="en-US" smtClean="0"/>
+              <a:rPr lang="en-US"/>
               <a:t>Click to edit Master title style</a:t>
             </a:r>
-            <a:endParaRPr lang="en-US"/>
           </a:p>
         </p:txBody>
       </p:sp>
@@ -1893,7 +1905,7 @@
           <a:p>
             <a:fld id="{5BCAD085-E8A6-8845-BD4E-CB4CCA059FC4}" type="datetimeFigureOut">
               <a:rPr lang="en-US" smtClean="0"/>
-              <a:t>1/27/13</a:t>
+              <a:t>10/23/2026</a:t>
             </a:fld>
             <a:endParaRPr lang="en-US"/>
           </a:p>
@@ -1988,7 +2000,7 @@
           <a:p>
             <a:fld id="{5BCAD085-E8A6-8845-BD4E-CB4CCA059FC4}" type="datetimeFigureOut">
               <a:rPr lang="en-US" smtClean="0"/>
-              <a:t>1/27/13</a:t>
+              <a:t>10/23/2026</a:t>
             </a:fld>
             <a:endParaRPr lang="en-US"/>
           </a:p>
@@ -2091,10 +2103,9 @@
           </a:lstStyle>
           <a:p>
             <a:r>
-              <a:rPr lang="en-US" smtClean="0"/>
+              <a:rPr lang="en-US"/>
               <a:t>Click to edit Master title style</a:t>
             </a:r>
-            <a:endParaRPr lang="en-US"/>
           </a:p>
         </p:txBody>
       </p:sp>
@@ -2148,38 +2159,37 @@
           <a:p>
             <a:pPr lvl="0"/>
             <a:r>
-              <a:rPr lang="en-US" smtClean="0"/>
+              <a:rPr lang="en-US"/>
               <a:t>Click to edit Master text styles</a:t>
             </a:r>
           </a:p>
           <a:p>
             <a:pPr lvl="1"/>
             <a:r>
-              <a:rPr lang="en-US" smtClean="0"/>
+              <a:rPr lang="en-US"/>
               <a:t>Second level</a:t>
             </a:r>
           </a:p>
           <a:p>
             <a:pPr lvl="2"/>
             <a:r>
-              <a:rPr lang="en-US" smtClean="0"/>
+              <a:rPr lang="en-US"/>
               <a:t>Third level</a:t>
             </a:r>
           </a:p>
           <a:p>
             <a:pPr lvl="3"/>
             <a:r>
-              <a:rPr lang="en-US" smtClean="0"/>
+              <a:rPr lang="en-US"/>
               <a:t>Fourth level</a:t>
             </a:r>
           </a:p>
           <a:p>
             <a:pPr lvl="4"/>
             <a:r>
-              <a:rPr lang="en-US" smtClean="0"/>
+              <a:rPr lang="en-US"/>
               <a:t>Fifth level</a:t>
             </a:r>
-            <a:endParaRPr lang="en-US"/>
           </a:p>
         </p:txBody>
       </p:sp>
@@ -2242,7 +2252,7 @@
           <a:p>
             <a:pPr lvl="0"/>
             <a:r>
-              <a:rPr lang="en-US" smtClean="0"/>
+              <a:rPr lang="en-US"/>
               <a:t>Click to edit Master text styles</a:t>
             </a:r>
           </a:p>
@@ -2265,7 +2275,7 @@
           <a:p>
             <a:fld id="{5BCAD085-E8A6-8845-BD4E-CB4CCA059FC4}" type="datetimeFigureOut">
               <a:rPr lang="en-US" smtClean="0"/>
-              <a:t>1/27/13</a:t>
+              <a:t>10/23/2026</a:t>
             </a:fld>
             <a:endParaRPr lang="en-US"/>
           </a:p>
@@ -2368,10 +2378,9 @@
           </a:lstStyle>
           <a:p>
             <a:r>
-              <a:rPr lang="en-US" smtClean="0"/>
+              <a:rPr lang="en-US"/>
               <a:t>Click to edit Master title style</a:t>
             </a:r>
-            <a:endParaRPr lang="en-US"/>
           </a:p>
         </p:txBody>
       </p:sp>
@@ -2495,7 +2504,7 @@
           <a:p>
             <a:pPr lvl="0"/>
             <a:r>
-              <a:rPr lang="en-US" smtClean="0"/>
+              <a:rPr lang="en-US"/>
               <a:t>Click to edit Master text styles</a:t>
             </a:r>
           </a:p>
@@ -2518,7 +2527,7 @@
           <a:p>
             <a:fld id="{5BCAD085-E8A6-8845-BD4E-CB4CCA059FC4}" type="datetimeFigureOut">
               <a:rPr lang="en-US" smtClean="0"/>
-              <a:t>1/27/13</a:t>
+              <a:t>10/23/2026</a:t>
             </a:fld>
             <a:endParaRPr lang="en-US"/>
           </a:p>
@@ -2627,10 +2636,9 @@
           <a:lstStyle/>
           <a:p>
             <a:r>
-              <a:rPr lang="en-US" smtClean="0"/>
+              <a:rPr lang="en-US"/>
               <a:t>Click to edit Master title style</a:t>
             </a:r>
-            <a:endParaRPr lang="en-US"/>
           </a:p>
         </p:txBody>
       </p:sp>
@@ -2661,38 +2669,37 @@
           <a:p>
             <a:pPr lvl="0"/>
             <a:r>
-              <a:rPr lang="en-US" smtClean="0"/>
+              <a:rPr lang="en-US"/>
               <a:t>Click to edit Master text styles</a:t>
             </a:r>
           </a:p>
           <a:p>
             <a:pPr lvl="1"/>
             <a:r>
-              <a:rPr lang="en-US" smtClean="0"/>
+              <a:rPr lang="en-US"/>
               <a:t>Second level</a:t>
             </a:r>
           </a:p>
           <a:p>
             <a:pPr lvl="2"/>
             <a:r>
-              <a:rPr lang="en-US" smtClean="0"/>
+              <a:rPr lang="en-US"/>
               <a:t>Third level</a:t>
             </a:r>
           </a:p>
           <a:p>
             <a:pPr lvl="3"/>
             <a:r>
-              <a:rPr lang="en-US" smtClean="0"/>
+              <a:rPr lang="en-US"/>
               <a:t>Fourth level</a:t>
             </a:r>
           </a:p>
           <a:p>
             <a:pPr lvl="4"/>
             <a:r>
-              <a:rPr lang="en-US" smtClean="0"/>
+              <a:rPr lang="en-US"/>
               <a:t>Fifth level</a:t>
             </a:r>
-            <a:endParaRPr lang="en-US"/>
           </a:p>
         </p:txBody>
       </p:sp>
@@ -2731,7 +2738,7 @@
           <a:p>
             <a:fld id="{5BCAD085-E8A6-8845-BD4E-CB4CCA059FC4}" type="datetimeFigureOut">
               <a:rPr lang="en-US" smtClean="0"/>
-              <a:t>1/27/13</a:t>
+              <a:t>10/23/2026</a:t>
             </a:fld>
             <a:endParaRPr lang="en-US"/>
           </a:p>
@@ -3090,35 +3097,75 @@
 </file>
 
 <file path=ppt/slides/slide1.xml><?xml version="1.0" encoding="utf-8"?>
-<p:sld xmlns:a="http://schemas.openxmlformats.org/drawingml/2006/main" xmlns:p="http://schemas.openxmlformats.org/presentationml/2006/main" xmlns:r="http://schemas.openxmlformats.org/officeDocument/2006/relationships">
+<p:sld xmlns:a="http://schemas.openxmlformats.org/drawingml/2006/main" xmlns:r="http://schemas.openxmlformats.org/officeDocument/2006/relationships" xmlns:p="http://schemas.openxmlformats.org/presentationml/2006/main">
   <p:cSld>
+    <p:bg>
+      <p:bgPr>
+        <a:solidFill>
+          <a:srgbClr val="FAF8FF"/>
+        </a:solidFill>
+        <a:effectLst/>
+      </p:bgPr>
+    </p:bg>
     <p:spTree>
       <p:nvGrpSpPr>
         <p:cNvPr id="1" name=""/>
         <p:cNvGrpSpPr/>
         <p:nvPr/>
       </p:nvGrpSpPr>
-      <p:grpSpPr/>
-      <p:sp>
-        <p:nvSpPr>
-          <p:cNvPr id="2" name="Rectangle 1"/>
+      <p:grpSpPr>
+        <a:xfrm>
+          <a:off x="0" y="0"/>
+          <a:ext cx="0" cy="0"/>
+          <a:chOff x="0" y="0"/>
+          <a:chExt cx="0" cy="0"/>
+        </a:xfrm>
+      </p:grpSpPr>
+      <p:pic>
+        <p:nvPicPr>
+          <p:cNvPr id="2" name="Picture 1" descr="image.png"/>
+          <p:cNvPicPr>
+            <a:picLocks noChangeAspect="1"/>
+          </p:cNvPicPr>
+          <p:nvPr/>
+        </p:nvPicPr>
+        <p:blipFill>
+          <a:blip r:embed="rId2"/>
+          <a:stretch>
+            <a:fillRect/>
+          </a:stretch>
+        </p:blipFill>
+        <p:spPr>
+          <a:xfrm>
+            <a:off x="0" y="0"/>
+            <a:ext cx="12192000" cy="6858000"/>
+          </a:xfrm>
+          <a:prstGeom prst="rect">
+            <a:avLst/>
+          </a:prstGeom>
+        </p:spPr>
+      </p:pic>
+      <p:sp>
+        <p:nvSpPr>
+          <p:cNvPr id="3" name="Rectangle 2"/>
           <p:cNvSpPr/>
           <p:nvPr/>
         </p:nvSpPr>
         <p:spPr>
           <a:xfrm>
-            <a:off x="0" y="0"/>
-            <a:ext cx="12188952" cy="6858000"/>
+            <a:off x="9525" y="9525"/>
+            <a:ext cx="12172950" cy="57150"/>
           </a:xfrm>
           <a:prstGeom prst="rect">
             <a:avLst/>
           </a:prstGeom>
           <a:solidFill>
-            <a:srgbClr val="243B31"/>
+            <a:srgbClr val="903C74"/>
           </a:solidFill>
           <a:ln>
             <a:noFill/>
           </a:ln>
+          <a:effectLst/>
         </p:spPr>
         <p:style>
           <a:lnRef idx="1">
@@ -3139,29 +3186,31 @@
           <a:lstStyle/>
           <a:p>
             <a:pPr algn="ctr"/>
-          </a:p>
-        </p:txBody>
-      </p:sp>
-      <p:sp>
-        <p:nvSpPr>
-          <p:cNvPr id="3" name="Rectangle 2"/>
+            <a:endParaRPr/>
+          </a:p>
+        </p:txBody>
+      </p:sp>
+      <p:sp>
+        <p:nvSpPr>
+          <p:cNvPr id="4" name="Rectangle 3"/>
           <p:cNvSpPr/>
           <p:nvPr/>
         </p:nvSpPr>
         <p:spPr>
           <a:xfrm>
-            <a:off x="0" y="0"/>
-            <a:ext cx="201168" cy="6858000"/>
+            <a:off x="9525" y="6791325"/>
+            <a:ext cx="12172950" cy="57150"/>
           </a:xfrm>
           <a:prstGeom prst="rect">
             <a:avLst/>
           </a:prstGeom>
           <a:solidFill>
-            <a:srgbClr val="CFE870"/>
+            <a:srgbClr val="903C74"/>
           </a:solidFill>
           <a:ln>
             <a:noFill/>
           </a:ln>
+          <a:effectLst/>
         </p:spPr>
         <p:style>
           <a:lnRef idx="1">
@@ -3182,29 +3231,33 @@
           <a:lstStyle/>
           <a:p>
             <a:pPr algn="ctr"/>
-          </a:p>
-        </p:txBody>
-      </p:sp>
-      <p:sp>
-        <p:nvSpPr>
-          <p:cNvPr id="4" name="Rectangle 3"/>
+            <a:endParaRPr/>
+          </a:p>
+        </p:txBody>
+      </p:sp>
+      <p:sp>
+        <p:nvSpPr>
+          <p:cNvPr id="5" name="Rounded Rectangle 4"/>
           <p:cNvSpPr/>
           <p:nvPr/>
         </p:nvSpPr>
         <p:spPr>
           <a:xfrm>
-            <a:off x="914400" y="2011680"/>
-            <a:ext cx="1097280" cy="1097280"/>
-          </a:xfrm>
-          <a:prstGeom prst="rect">
-            <a:avLst/>
+            <a:off x="542925" y="2639317"/>
+            <a:ext cx="11106150" cy="1198215"/>
+          </a:xfrm>
+          <a:prstGeom prst="roundRect">
+            <a:avLst>
+              <a:gd name="adj" fmla="val 9539"/>
+            </a:avLst>
           </a:prstGeom>
           <a:solidFill>
-            <a:srgbClr val="CFE870"/>
+            <a:srgbClr val="FFFFFF"/>
           </a:solidFill>
           <a:ln>
             <a:noFill/>
           </a:ln>
+          <a:effectLst/>
         </p:spPr>
         <p:style>
           <a:lnRef idx="1">
@@ -3225,169 +3278,35 @@
           <a:lstStyle/>
           <a:p>
             <a:pPr algn="ctr"/>
-          </a:p>
-        </p:txBody>
-      </p:sp>
-      <p:sp>
-        <p:nvSpPr>
-          <p:cNvPr id="5" name="TextBox 4"/>
-          <p:cNvSpPr txBox="1"/>
-          <p:nvPr/>
-        </p:nvSpPr>
-        <p:spPr>
-          <a:xfrm>
-            <a:off x="1005840" y="2148840"/>
-            <a:ext cx="914400" cy="777240"/>
-          </a:xfrm>
-          <a:prstGeom prst="rect">
-            <a:avLst/>
-          </a:prstGeom>
-          <a:noFill/>
-        </p:spPr>
-        <p:txBody>
-          <a:bodyPr wrap="square">
-            <a:spAutoFit/>
-          </a:bodyPr>
-          <a:lstStyle/>
-          <a:p>
-            <a:pPr algn="ctr"/>
-            <a:r>
-              <a:rPr sz="4200" b="1" i="1">
-                <a:solidFill>
-                  <a:srgbClr val="243B31"/>
-                </a:solidFill>
-                <a:latin typeface="Georgia"/>
-              </a:rPr>
-              <a:t>c.</a:t>
-            </a:r>
-          </a:p>
-        </p:txBody>
-      </p:sp>
-      <p:sp>
-        <p:nvSpPr>
-          <p:cNvPr id="6" name="TextBox 5"/>
-          <p:cNvSpPr txBox="1"/>
-          <p:nvPr/>
-        </p:nvSpPr>
-        <p:spPr>
-          <a:xfrm>
-            <a:off x="2286000" y="1920240"/>
-            <a:ext cx="8686800" cy="1005840"/>
-          </a:xfrm>
-          <a:prstGeom prst="rect">
-            <a:avLst/>
-          </a:prstGeom>
-          <a:noFill/>
-        </p:spPr>
-        <p:txBody>
-          <a:bodyPr wrap="square">
-            <a:spAutoFit/>
-          </a:bodyPr>
-          <a:lstStyle/>
-          <a:p>
-            <a:pPr algn="l"/>
-            <a:r>
-              <a:rPr sz="6200" b="1" i="0">
-                <a:solidFill>
-                  <a:srgbClr val="CFE870"/>
-                </a:solidFill>
-                <a:latin typeface="Calibri"/>
-              </a:rPr>
-              <a:t>Campus Circle</a:t>
-            </a:r>
-          </a:p>
-        </p:txBody>
-      </p:sp>
-      <p:sp>
-        <p:nvSpPr>
-          <p:cNvPr id="7" name="TextBox 6"/>
-          <p:cNvSpPr txBox="1"/>
-          <p:nvPr/>
-        </p:nvSpPr>
-        <p:spPr>
-          <a:xfrm>
-            <a:off x="2286000" y="2880360"/>
-            <a:ext cx="8686800" cy="594360"/>
-          </a:xfrm>
-          <a:prstGeom prst="rect">
-            <a:avLst/>
-          </a:prstGeom>
-          <a:noFill/>
-        </p:spPr>
-        <p:txBody>
-          <a:bodyPr wrap="square">
-            <a:spAutoFit/>
-          </a:bodyPr>
-          <a:lstStyle/>
-          <a:p>
-            <a:pPr algn="l"/>
-            <a:r>
-              <a:rPr sz="2400" b="0" i="0">
-                <a:solidFill>
-                  <a:srgbClr val="FFFEFA"/>
-                </a:solidFill>
-                <a:latin typeface="Calibri"/>
-              </a:rPr>
-              <a:t>Campus Event Management Platform</a:t>
-            </a:r>
-          </a:p>
-        </p:txBody>
-      </p:sp>
-      <p:sp>
-        <p:nvSpPr>
-          <p:cNvPr id="8" name="TextBox 7"/>
-          <p:cNvSpPr txBox="1"/>
-          <p:nvPr/>
-        </p:nvSpPr>
-        <p:spPr>
-          <a:xfrm>
-            <a:off x="2286000" y="3520440"/>
-            <a:ext cx="8686800" cy="457200"/>
-          </a:xfrm>
-          <a:prstGeom prst="rect">
-            <a:avLst/>
-          </a:prstGeom>
-          <a:noFill/>
-        </p:spPr>
-        <p:txBody>
-          <a:bodyPr wrap="square">
-            <a:spAutoFit/>
-          </a:bodyPr>
-          <a:lstStyle/>
-          <a:p>
-            <a:pPr algn="l"/>
-            <a:r>
-              <a:rPr sz="1600" b="0" i="1">
-                <a:solidFill>
-                  <a:srgbClr val="76817B"/>
-                </a:solidFill>
-                <a:latin typeface="Calibri"/>
-              </a:rPr>
-              <a:t>Discover  ·  Register  ·  Celebrate</a:t>
-            </a:r>
-          </a:p>
-        </p:txBody>
-      </p:sp>
-      <p:sp>
-        <p:nvSpPr>
-          <p:cNvPr id="9" name="Rectangle 8"/>
+            <a:endParaRPr/>
+          </a:p>
+        </p:txBody>
+      </p:sp>
+      <p:sp>
+        <p:nvSpPr>
+          <p:cNvPr id="6" name="Rounded Rectangle 5"/>
           <p:cNvSpPr/>
           <p:nvPr/>
         </p:nvSpPr>
         <p:spPr>
           <a:xfrm>
-            <a:off x="0" y="6217920"/>
-            <a:ext cx="12188952" cy="640080"/>
-          </a:xfrm>
-          <a:prstGeom prst="rect">
-            <a:avLst/>
+            <a:off x="542925" y="5057626"/>
+            <a:ext cx="7067550" cy="1371600"/>
+          </a:xfrm>
+          <a:prstGeom prst="roundRect">
+            <a:avLst>
+              <a:gd name="adj" fmla="val 8333"/>
+            </a:avLst>
           </a:prstGeom>
           <a:solidFill>
-            <a:srgbClr val="1A2E26"/>
+            <a:srgbClr val="FFFFFF"/>
           </a:solidFill>
-          <a:ln>
-            <a:noFill/>
+          <a:ln w="9525">
+            <a:solidFill>
+              <a:srgbClr val="E9D5FF"/>
+            </a:solidFill>
           </a:ln>
+          <a:effectLst/>
         </p:spPr>
         <p:style>
           <a:lnRef idx="1">
@@ -3408,41 +3327,1173 @@
           <a:lstStyle/>
           <a:p>
             <a:pPr algn="ctr"/>
-          </a:p>
-        </p:txBody>
-      </p:sp>
-      <p:sp>
-        <p:nvSpPr>
-          <p:cNvPr id="10" name="TextBox 9"/>
-          <p:cNvSpPr txBox="1"/>
-          <p:nvPr/>
-        </p:nvSpPr>
-        <p:spPr>
-          <a:xfrm>
-            <a:off x="457200" y="6263640"/>
-            <a:ext cx="10972800" cy="457200"/>
-          </a:xfrm>
-          <a:prstGeom prst="rect">
-            <a:avLst/>
-          </a:prstGeom>
-          <a:noFill/>
-        </p:spPr>
-        <p:txBody>
-          <a:bodyPr wrap="square">
-            <a:spAutoFit/>
-          </a:bodyPr>
-          <a:lstStyle/>
-          <a:p>
-            <a:pPr algn="ctr"/>
-            <a:r>
-              <a:rPr sz="1300" b="0" i="0">
-                <a:solidFill>
-                  <a:srgbClr val="CFE870"/>
-                </a:solidFill>
-                <a:latin typeface="Calibri"/>
-              </a:rPr>
-              <a:t>React + Vite  |  Flask REST API  |  PostgreSQL  |  Gemini AI</a:t>
-            </a:r>
+            <a:endParaRPr/>
+          </a:p>
+        </p:txBody>
+      </p:sp>
+      <p:sp>
+        <p:nvSpPr>
+          <p:cNvPr id="7" name="Rounded Rectangle 6"/>
+          <p:cNvSpPr/>
+          <p:nvPr/>
+        </p:nvSpPr>
+        <p:spPr>
+          <a:xfrm>
+            <a:off x="7839075" y="5057626"/>
+            <a:ext cx="3810000" cy="1371600"/>
+          </a:xfrm>
+          <a:prstGeom prst="roundRect">
+            <a:avLst>
+              <a:gd name="adj" fmla="val 8333"/>
+            </a:avLst>
+          </a:prstGeom>
+          <a:solidFill>
+            <a:srgbClr val="FFFFFF"/>
+          </a:solidFill>
+          <a:ln>
+            <a:noFill/>
+          </a:ln>
+          <a:effectLst/>
+        </p:spPr>
+        <p:style>
+          <a:lnRef idx="1">
+            <a:schemeClr val="accent1"/>
+          </a:lnRef>
+          <a:fillRef idx="3">
+            <a:schemeClr val="accent1"/>
+          </a:fillRef>
+          <a:effectRef idx="2">
+            <a:schemeClr val="accent1"/>
+          </a:effectRef>
+          <a:fontRef idx="minor">
+            <a:schemeClr val="lt1"/>
+          </a:fontRef>
+        </p:style>
+        <p:txBody>
+          <a:bodyPr rtlCol="0" anchor="ctr"/>
+          <a:lstStyle/>
+          <a:p>
+            <a:pPr algn="ctr"/>
+            <a:endParaRPr/>
+          </a:p>
+        </p:txBody>
+      </p:sp>
+      <p:sp>
+        <p:nvSpPr>
+          <p:cNvPr id="8" name="Rectangle 7"/>
+          <p:cNvSpPr/>
+          <p:nvPr/>
+        </p:nvSpPr>
+        <p:spPr>
+          <a:xfrm>
+            <a:off x="542925" y="3818483"/>
+            <a:ext cx="11106150" cy="19050"/>
+          </a:xfrm>
+          <a:prstGeom prst="rect">
+            <a:avLst/>
+          </a:prstGeom>
+          <a:solidFill>
+            <a:srgbClr val="A855F7"/>
+          </a:solidFill>
+          <a:ln>
+            <a:noFill/>
+          </a:ln>
+          <a:effectLst/>
+        </p:spPr>
+        <p:style>
+          <a:lnRef idx="1">
+            <a:schemeClr val="accent1"/>
+          </a:lnRef>
+          <a:fillRef idx="3">
+            <a:schemeClr val="accent1"/>
+          </a:fillRef>
+          <a:effectRef idx="2">
+            <a:schemeClr val="accent1"/>
+          </a:effectRef>
+          <a:fontRef idx="minor">
+            <a:schemeClr val="lt1"/>
+          </a:fontRef>
+        </p:style>
+        <p:txBody>
+          <a:bodyPr rtlCol="0" anchor="ctr"/>
+          <a:lstStyle/>
+          <a:p>
+            <a:pPr algn="ctr"/>
+            <a:endParaRPr/>
+          </a:p>
+        </p:txBody>
+      </p:sp>
+      <p:sp>
+        <p:nvSpPr>
+          <p:cNvPr id="9" name="Rectangle 8"/>
+          <p:cNvSpPr/>
+          <p:nvPr/>
+        </p:nvSpPr>
+        <p:spPr>
+          <a:xfrm>
+            <a:off x="542925" y="2639317"/>
+            <a:ext cx="11106150" cy="19050"/>
+          </a:xfrm>
+          <a:prstGeom prst="rect">
+            <a:avLst/>
+          </a:prstGeom>
+          <a:solidFill>
+            <a:srgbClr val="A855F7"/>
+          </a:solidFill>
+          <a:ln>
+            <a:noFill/>
+          </a:ln>
+          <a:effectLst/>
+        </p:spPr>
+        <p:style>
+          <a:lnRef idx="1">
+            <a:schemeClr val="accent1"/>
+          </a:lnRef>
+          <a:fillRef idx="3">
+            <a:schemeClr val="accent1"/>
+          </a:fillRef>
+          <a:effectRef idx="2">
+            <a:schemeClr val="accent1"/>
+          </a:effectRef>
+          <a:fontRef idx="minor">
+            <a:schemeClr val="lt1"/>
+          </a:fontRef>
+        </p:style>
+        <p:txBody>
+          <a:bodyPr rtlCol="0" anchor="ctr"/>
+          <a:lstStyle/>
+          <a:p>
+            <a:pPr algn="ctr"/>
+            <a:endParaRPr/>
+          </a:p>
+        </p:txBody>
+      </p:sp>
+      <p:sp>
+        <p:nvSpPr>
+          <p:cNvPr id="10" name="Rectangle 9"/>
+          <p:cNvSpPr/>
+          <p:nvPr/>
+        </p:nvSpPr>
+        <p:spPr>
+          <a:xfrm>
+            <a:off x="542925" y="2639317"/>
+            <a:ext cx="76200" cy="1198215"/>
+          </a:xfrm>
+          <a:prstGeom prst="rect">
+            <a:avLst/>
+          </a:prstGeom>
+          <a:solidFill>
+            <a:srgbClr val="7E22CE"/>
+          </a:solidFill>
+          <a:ln>
+            <a:noFill/>
+          </a:ln>
+          <a:effectLst/>
+        </p:spPr>
+        <p:style>
+          <a:lnRef idx="1">
+            <a:schemeClr val="accent1"/>
+          </a:lnRef>
+          <a:fillRef idx="3">
+            <a:schemeClr val="accent1"/>
+          </a:fillRef>
+          <a:effectRef idx="2">
+            <a:schemeClr val="accent1"/>
+          </a:effectRef>
+          <a:fontRef idx="minor">
+            <a:schemeClr val="lt1"/>
+          </a:fontRef>
+        </p:style>
+        <p:txBody>
+          <a:bodyPr rtlCol="0" anchor="ctr"/>
+          <a:lstStyle/>
+          <a:p>
+            <a:pPr algn="ctr"/>
+            <a:endParaRPr/>
+          </a:p>
+        </p:txBody>
+      </p:sp>
+      <p:sp>
+        <p:nvSpPr>
+          <p:cNvPr id="11" name="Rectangle 10"/>
+          <p:cNvSpPr/>
+          <p:nvPr/>
+        </p:nvSpPr>
+        <p:spPr>
+          <a:xfrm>
+            <a:off x="11630025" y="2639317"/>
+            <a:ext cx="19050" cy="1198215"/>
+          </a:xfrm>
+          <a:prstGeom prst="rect">
+            <a:avLst/>
+          </a:prstGeom>
+          <a:solidFill>
+            <a:srgbClr val="A855F7"/>
+          </a:solidFill>
+          <a:ln>
+            <a:noFill/>
+          </a:ln>
+          <a:effectLst/>
+        </p:spPr>
+        <p:style>
+          <a:lnRef idx="1">
+            <a:schemeClr val="accent1"/>
+          </a:lnRef>
+          <a:fillRef idx="3">
+            <a:schemeClr val="accent1"/>
+          </a:fillRef>
+          <a:effectRef idx="2">
+            <a:schemeClr val="accent1"/>
+          </a:effectRef>
+          <a:fontRef idx="minor">
+            <a:schemeClr val="lt1"/>
+          </a:fontRef>
+        </p:style>
+        <p:txBody>
+          <a:bodyPr rtlCol="0" anchor="ctr"/>
+          <a:lstStyle/>
+          <a:p>
+            <a:pPr algn="ctr"/>
+            <a:endParaRPr/>
+          </a:p>
+        </p:txBody>
+      </p:sp>
+      <p:sp>
+        <p:nvSpPr>
+          <p:cNvPr id="12" name="Rectangle 11"/>
+          <p:cNvSpPr/>
+          <p:nvPr/>
+        </p:nvSpPr>
+        <p:spPr>
+          <a:xfrm>
+            <a:off x="7839075" y="6419701"/>
+            <a:ext cx="3810000" cy="9525"/>
+          </a:xfrm>
+          <a:prstGeom prst="rect">
+            <a:avLst/>
+          </a:prstGeom>
+          <a:solidFill>
+            <a:srgbClr val="FDE68A"/>
+          </a:solidFill>
+          <a:ln>
+            <a:noFill/>
+          </a:ln>
+          <a:effectLst/>
+        </p:spPr>
+        <p:style>
+          <a:lnRef idx="1">
+            <a:schemeClr val="accent1"/>
+          </a:lnRef>
+          <a:fillRef idx="3">
+            <a:schemeClr val="accent1"/>
+          </a:fillRef>
+          <a:effectRef idx="2">
+            <a:schemeClr val="accent1"/>
+          </a:effectRef>
+          <a:fontRef idx="minor">
+            <a:schemeClr val="lt1"/>
+          </a:fontRef>
+        </p:style>
+        <p:txBody>
+          <a:bodyPr rtlCol="0" anchor="ctr"/>
+          <a:lstStyle/>
+          <a:p>
+            <a:pPr algn="ctr"/>
+            <a:endParaRPr/>
+          </a:p>
+        </p:txBody>
+      </p:sp>
+      <p:sp>
+        <p:nvSpPr>
+          <p:cNvPr id="13" name="Rectangle 12"/>
+          <p:cNvSpPr/>
+          <p:nvPr/>
+        </p:nvSpPr>
+        <p:spPr>
+          <a:xfrm>
+            <a:off x="7839075" y="5057626"/>
+            <a:ext cx="3810000" cy="9525"/>
+          </a:xfrm>
+          <a:prstGeom prst="rect">
+            <a:avLst/>
+          </a:prstGeom>
+          <a:solidFill>
+            <a:srgbClr val="FDE68A"/>
+          </a:solidFill>
+          <a:ln>
+            <a:noFill/>
+          </a:ln>
+          <a:effectLst/>
+        </p:spPr>
+        <p:style>
+          <a:lnRef idx="1">
+            <a:schemeClr val="accent1"/>
+          </a:lnRef>
+          <a:fillRef idx="3">
+            <a:schemeClr val="accent1"/>
+          </a:fillRef>
+          <a:effectRef idx="2">
+            <a:schemeClr val="accent1"/>
+          </a:effectRef>
+          <a:fontRef idx="minor">
+            <a:schemeClr val="lt1"/>
+          </a:fontRef>
+        </p:style>
+        <p:txBody>
+          <a:bodyPr rtlCol="0" anchor="ctr"/>
+          <a:lstStyle/>
+          <a:p>
+            <a:pPr algn="ctr"/>
+            <a:endParaRPr/>
+          </a:p>
+        </p:txBody>
+      </p:sp>
+      <p:sp>
+        <p:nvSpPr>
+          <p:cNvPr id="14" name="Rectangle 13"/>
+          <p:cNvSpPr/>
+          <p:nvPr/>
+        </p:nvSpPr>
+        <p:spPr>
+          <a:xfrm>
+            <a:off x="7839075" y="5057626"/>
+            <a:ext cx="47625" cy="1371600"/>
+          </a:xfrm>
+          <a:prstGeom prst="rect">
+            <a:avLst/>
+          </a:prstGeom>
+          <a:solidFill>
+            <a:srgbClr val="D97706"/>
+          </a:solidFill>
+          <a:ln>
+            <a:noFill/>
+          </a:ln>
+          <a:effectLst/>
+        </p:spPr>
+        <p:style>
+          <a:lnRef idx="1">
+            <a:schemeClr val="accent1"/>
+          </a:lnRef>
+          <a:fillRef idx="3">
+            <a:schemeClr val="accent1"/>
+          </a:fillRef>
+          <a:effectRef idx="2">
+            <a:schemeClr val="accent1"/>
+          </a:effectRef>
+          <a:fontRef idx="minor">
+            <a:schemeClr val="lt1"/>
+          </a:fontRef>
+        </p:style>
+        <p:txBody>
+          <a:bodyPr rtlCol="0" anchor="ctr"/>
+          <a:lstStyle/>
+          <a:p>
+            <a:pPr algn="ctr"/>
+            <a:endParaRPr/>
+          </a:p>
+        </p:txBody>
+      </p:sp>
+      <p:sp>
+        <p:nvSpPr>
+          <p:cNvPr id="15" name="Rectangle 14"/>
+          <p:cNvSpPr/>
+          <p:nvPr/>
+        </p:nvSpPr>
+        <p:spPr>
+          <a:xfrm>
+            <a:off x="11639550" y="5057626"/>
+            <a:ext cx="9525" cy="1371600"/>
+          </a:xfrm>
+          <a:prstGeom prst="rect">
+            <a:avLst/>
+          </a:prstGeom>
+          <a:solidFill>
+            <a:srgbClr val="FDE68A"/>
+          </a:solidFill>
+          <a:ln>
+            <a:noFill/>
+          </a:ln>
+          <a:effectLst/>
+        </p:spPr>
+        <p:style>
+          <a:lnRef idx="1">
+            <a:schemeClr val="accent1"/>
+          </a:lnRef>
+          <a:fillRef idx="3">
+            <a:schemeClr val="accent1"/>
+          </a:fillRef>
+          <a:effectRef idx="2">
+            <a:schemeClr val="accent1"/>
+          </a:effectRef>
+          <a:fontRef idx="minor">
+            <a:schemeClr val="lt1"/>
+          </a:fontRef>
+        </p:style>
+        <p:txBody>
+          <a:bodyPr rtlCol="0" anchor="ctr"/>
+          <a:lstStyle/>
+          <a:p>
+            <a:pPr algn="ctr"/>
+            <a:endParaRPr/>
+          </a:p>
+        </p:txBody>
+      </p:sp>
+      <p:sp>
+        <p:nvSpPr>
+          <p:cNvPr id="16" name="Rounded Rectangle 15"/>
+          <p:cNvSpPr/>
+          <p:nvPr/>
+        </p:nvSpPr>
+        <p:spPr>
+          <a:xfrm>
+            <a:off x="8115300" y="5643413"/>
+            <a:ext cx="3295650" cy="466725"/>
+          </a:xfrm>
+          <a:prstGeom prst="roundRect">
+            <a:avLst>
+              <a:gd name="adj" fmla="val 16326"/>
+            </a:avLst>
+          </a:prstGeom>
+          <a:solidFill>
+            <a:srgbClr val="FFFBEB"/>
+          </a:solidFill>
+          <a:ln w="9525">
+            <a:solidFill>
+              <a:srgbClr val="FEF3C7"/>
+            </a:solidFill>
+          </a:ln>
+          <a:effectLst/>
+        </p:spPr>
+        <p:style>
+          <a:lnRef idx="1">
+            <a:schemeClr val="accent1"/>
+          </a:lnRef>
+          <a:fillRef idx="3">
+            <a:schemeClr val="accent1"/>
+          </a:fillRef>
+          <a:effectRef idx="2">
+            <a:schemeClr val="accent1"/>
+          </a:effectRef>
+          <a:fontRef idx="minor">
+            <a:schemeClr val="lt1"/>
+          </a:fontRef>
+        </p:style>
+        <p:txBody>
+          <a:bodyPr rtlCol="0" anchor="ctr"/>
+          <a:lstStyle/>
+          <a:p>
+            <a:pPr algn="ctr"/>
+            <a:endParaRPr/>
+          </a:p>
+        </p:txBody>
+      </p:sp>
+      <p:sp>
+        <p:nvSpPr>
+          <p:cNvPr id="17" name="Rounded Rectangle 16"/>
+          <p:cNvSpPr/>
+          <p:nvPr/>
+        </p:nvSpPr>
+        <p:spPr>
+          <a:xfrm>
+            <a:off x="781050" y="5571976"/>
+            <a:ext cx="1562100" cy="657225"/>
+          </a:xfrm>
+          <a:prstGeom prst="roundRect">
+            <a:avLst>
+              <a:gd name="adj" fmla="val 16326"/>
+            </a:avLst>
+          </a:prstGeom>
+          <a:solidFill>
+            <a:srgbClr val="FAF5FF"/>
+          </a:solidFill>
+          <a:ln w="9525">
+            <a:solidFill>
+              <a:srgbClr val="D8B4FE"/>
+            </a:solidFill>
+          </a:ln>
+          <a:effectLst/>
+        </p:spPr>
+        <p:style>
+          <a:lnRef idx="1">
+            <a:schemeClr val="accent1"/>
+          </a:lnRef>
+          <a:fillRef idx="3">
+            <a:schemeClr val="accent1"/>
+          </a:fillRef>
+          <a:effectRef idx="2">
+            <a:schemeClr val="accent1"/>
+          </a:effectRef>
+          <a:fontRef idx="minor">
+            <a:schemeClr val="lt1"/>
+          </a:fontRef>
+        </p:style>
+        <p:txBody>
+          <a:bodyPr rtlCol="0" anchor="ctr"/>
+          <a:lstStyle/>
+          <a:p>
+            <a:pPr algn="ctr"/>
+            <a:endParaRPr/>
+          </a:p>
+        </p:txBody>
+      </p:sp>
+      <p:sp>
+        <p:nvSpPr>
+          <p:cNvPr id="18" name="Rounded Rectangle 17"/>
+          <p:cNvSpPr/>
+          <p:nvPr/>
+        </p:nvSpPr>
+        <p:spPr>
+          <a:xfrm>
+            <a:off x="2457450" y="5543401"/>
+            <a:ext cx="1562100" cy="685800"/>
+          </a:xfrm>
+          <a:prstGeom prst="roundRect">
+            <a:avLst>
+              <a:gd name="adj" fmla="val 11111"/>
+            </a:avLst>
+          </a:prstGeom>
+          <a:solidFill>
+            <a:srgbClr val="FAF5FF"/>
+          </a:solidFill>
+          <a:ln w="9525">
+            <a:solidFill>
+              <a:srgbClr val="D8B4FE"/>
+            </a:solidFill>
+          </a:ln>
+          <a:effectLst/>
+        </p:spPr>
+        <p:style>
+          <a:lnRef idx="1">
+            <a:schemeClr val="accent1"/>
+          </a:lnRef>
+          <a:fillRef idx="3">
+            <a:schemeClr val="accent1"/>
+          </a:fillRef>
+          <a:effectRef idx="2">
+            <a:schemeClr val="accent1"/>
+          </a:effectRef>
+          <a:fontRef idx="minor">
+            <a:schemeClr val="lt1"/>
+          </a:fontRef>
+        </p:style>
+        <p:txBody>
+          <a:bodyPr rtlCol="0" anchor="ctr"/>
+          <a:lstStyle/>
+          <a:p>
+            <a:pPr algn="ctr"/>
+            <a:endParaRPr/>
+          </a:p>
+        </p:txBody>
+      </p:sp>
+      <p:sp>
+        <p:nvSpPr>
+          <p:cNvPr id="19" name="Rounded Rectangle 18"/>
+          <p:cNvSpPr/>
+          <p:nvPr/>
+        </p:nvSpPr>
+        <p:spPr>
+          <a:xfrm>
+            <a:off x="4133850" y="5543401"/>
+            <a:ext cx="1562100" cy="685800"/>
+          </a:xfrm>
+          <a:prstGeom prst="roundRect">
+            <a:avLst>
+              <a:gd name="adj" fmla="val 11111"/>
+            </a:avLst>
+          </a:prstGeom>
+          <a:solidFill>
+            <a:srgbClr val="FAF5FF"/>
+          </a:solidFill>
+          <a:ln w="9525">
+            <a:solidFill>
+              <a:srgbClr val="D8B4FE"/>
+            </a:solidFill>
+          </a:ln>
+          <a:effectLst/>
+        </p:spPr>
+        <p:style>
+          <a:lnRef idx="1">
+            <a:schemeClr val="accent1"/>
+          </a:lnRef>
+          <a:fillRef idx="3">
+            <a:schemeClr val="accent1"/>
+          </a:fillRef>
+          <a:effectRef idx="2">
+            <a:schemeClr val="accent1"/>
+          </a:effectRef>
+          <a:fontRef idx="minor">
+            <a:schemeClr val="lt1"/>
+          </a:fontRef>
+        </p:style>
+        <p:txBody>
+          <a:bodyPr rtlCol="0" anchor="ctr"/>
+          <a:lstStyle/>
+          <a:p>
+            <a:pPr algn="ctr"/>
+            <a:endParaRPr/>
+          </a:p>
+        </p:txBody>
+      </p:sp>
+      <p:sp>
+        <p:nvSpPr>
+          <p:cNvPr id="20" name="Rounded Rectangle 19"/>
+          <p:cNvSpPr/>
+          <p:nvPr/>
+        </p:nvSpPr>
+        <p:spPr>
+          <a:xfrm>
+            <a:off x="5810250" y="5543401"/>
+            <a:ext cx="1562100" cy="685800"/>
+          </a:xfrm>
+          <a:prstGeom prst="roundRect">
+            <a:avLst>
+              <a:gd name="adj" fmla="val 11111"/>
+            </a:avLst>
+          </a:prstGeom>
+          <a:solidFill>
+            <a:srgbClr val="FAF5FF"/>
+          </a:solidFill>
+          <a:ln w="9525">
+            <a:solidFill>
+              <a:srgbClr val="D8B4FE"/>
+            </a:solidFill>
+          </a:ln>
+          <a:effectLst/>
+        </p:spPr>
+        <p:style>
+          <a:lnRef idx="1">
+            <a:schemeClr val="accent1"/>
+          </a:lnRef>
+          <a:fillRef idx="3">
+            <a:schemeClr val="accent1"/>
+          </a:fillRef>
+          <a:effectRef idx="2">
+            <a:schemeClr val="accent1"/>
+          </a:effectRef>
+          <a:fontRef idx="minor">
+            <a:schemeClr val="lt1"/>
+          </a:fontRef>
+        </p:style>
+        <p:txBody>
+          <a:bodyPr rtlCol="0" anchor="ctr"/>
+          <a:lstStyle/>
+          <a:p>
+            <a:pPr algn="ctr"/>
+            <a:endParaRPr/>
+          </a:p>
+        </p:txBody>
+      </p:sp>
+      <p:pic>
+        <p:nvPicPr>
+          <p:cNvPr id="21" name="Picture 20" descr="image.png"/>
+          <p:cNvPicPr>
+            <a:picLocks noChangeAspect="1"/>
+          </p:cNvPicPr>
+          <p:nvPr/>
+        </p:nvPicPr>
+        <p:blipFill>
+          <a:blip r:embed="rId3"/>
+          <a:stretch>
+            <a:fillRect/>
+          </a:stretch>
+        </p:blipFill>
+        <p:spPr>
+          <a:xfrm>
+            <a:off x="542925" y="428625"/>
+            <a:ext cx="1828800" cy="762000"/>
+          </a:xfrm>
+          <a:prstGeom prst="rect">
+            <a:avLst/>
+          </a:prstGeom>
+        </p:spPr>
+      </p:pic>
+      <p:sp>
+        <p:nvSpPr>
+          <p:cNvPr id="22" name="TextBox 21"/>
+          <p:cNvSpPr txBox="1"/>
+          <p:nvPr/>
+        </p:nvSpPr>
+        <p:spPr>
+          <a:xfrm>
+            <a:off x="3485554" y="457200"/>
+            <a:ext cx="8163520" cy="238125"/>
+          </a:xfrm>
+          <a:prstGeom prst="rect">
+            <a:avLst/>
+          </a:prstGeom>
+          <a:noFill/>
+        </p:spPr>
+        <p:txBody>
+          <a:bodyPr wrap="none" lIns="0" tIns="0" rIns="0" bIns="0" anchor="t">
+            <a:spAutoFit/>
+          </a:bodyPr>
+          <a:lstStyle/>
+          <a:p>
+            <a:pPr algn="r"/>
+            <a:r>
+              <a:rPr sz="1575" b="1" i="0" u="none">
+                <a:solidFill>
+                  <a:srgbClr val="3B0764"/>
+                </a:solidFill>
+                <a:latin typeface="Montserrat"/>
+              </a:rPr>
+              <a:t>ER. PERUMAL MANIMEKALAI COLLEGE OF ENGINEERING</a:t>
+            </a:r>
+          </a:p>
+        </p:txBody>
+      </p:sp>
+      <p:sp>
+        <p:nvSpPr>
+          <p:cNvPr id="23" name="TextBox 22"/>
+          <p:cNvSpPr txBox="1"/>
+          <p:nvPr/>
+        </p:nvSpPr>
+        <p:spPr>
+          <a:xfrm>
+            <a:off x="7814220" y="714375"/>
+            <a:ext cx="3834854" cy="190500"/>
+          </a:xfrm>
+          <a:prstGeom prst="rect">
+            <a:avLst/>
+          </a:prstGeom>
+          <a:noFill/>
+        </p:spPr>
+        <p:txBody>
+          <a:bodyPr wrap="square" lIns="0" tIns="0" rIns="0" bIns="0" anchor="t">
+            <a:spAutoFit/>
+          </a:bodyPr>
+          <a:lstStyle/>
+          <a:p>
+            <a:pPr algn="r"/>
+            <a:r>
+              <a:rPr sz="975" b="1" i="0" u="none">
+                <a:solidFill>
+                  <a:srgbClr val="B45309"/>
+                </a:solidFill>
+                <a:latin typeface="Poppins"/>
+              </a:rPr>
+              <a:t>AN AUTONOMOUS INSTITUTION • HOSUR – 635 117</a:t>
+            </a:r>
+          </a:p>
+        </p:txBody>
+      </p:sp>
+      <p:sp>
+        <p:nvSpPr>
+          <p:cNvPr id="24" name="TextBox 23"/>
+          <p:cNvSpPr txBox="1"/>
+          <p:nvPr/>
+        </p:nvSpPr>
+        <p:spPr>
+          <a:xfrm>
+            <a:off x="7907535" y="942975"/>
+            <a:ext cx="3741539" cy="219075"/>
+          </a:xfrm>
+          <a:prstGeom prst="rect">
+            <a:avLst/>
+          </a:prstGeom>
+          <a:noFill/>
+        </p:spPr>
+        <p:txBody>
+          <a:bodyPr wrap="square" lIns="0" tIns="0" rIns="0" bIns="0" anchor="t">
+            <a:spAutoFit/>
+          </a:bodyPr>
+          <a:lstStyle/>
+          <a:p>
+            <a:pPr algn="r"/>
+            <a:r>
+              <a:rPr sz="1125" b="1" i="0" u="none">
+                <a:solidFill>
+                  <a:srgbClr val="6B21A8"/>
+                </a:solidFill>
+                <a:latin typeface="Poppins"/>
+              </a:rPr>
+              <a:t>DEPARTMENT OF INFORMATION TECHNOLOGY</a:t>
+            </a:r>
+          </a:p>
+        </p:txBody>
+      </p:sp>
+      <p:sp>
+        <p:nvSpPr>
+          <p:cNvPr id="25" name="TextBox 24"/>
+          <p:cNvSpPr txBox="1"/>
+          <p:nvPr/>
+        </p:nvSpPr>
+        <p:spPr>
+          <a:xfrm>
+            <a:off x="962025" y="2925067"/>
+            <a:ext cx="10420350" cy="190500"/>
+          </a:xfrm>
+          <a:prstGeom prst="rect">
+            <a:avLst/>
+          </a:prstGeom>
+          <a:noFill/>
+        </p:spPr>
+        <p:txBody>
+          <a:bodyPr wrap="square" lIns="0" tIns="0" rIns="0" bIns="0" anchor="t">
+            <a:spAutoFit/>
+          </a:bodyPr>
+          <a:lstStyle/>
+          <a:p>
+            <a:pPr algn="l"/>
+            <a:r>
+              <a:rPr sz="975" b="1" i="0" u="none">
+                <a:solidFill>
+                  <a:srgbClr val="B45309"/>
+                </a:solidFill>
+                <a:latin typeface="Poppins"/>
+              </a:rPr>
+              <a:t>PROJECT TITLE</a:t>
+            </a:r>
+          </a:p>
+        </p:txBody>
+      </p:sp>
+      <p:sp>
+        <p:nvSpPr>
+          <p:cNvPr id="26" name="TextBox 25"/>
+          <p:cNvSpPr txBox="1"/>
+          <p:nvPr/>
+        </p:nvSpPr>
+        <p:spPr>
+          <a:xfrm>
+            <a:off x="962025" y="3191767"/>
+            <a:ext cx="7315200" cy="335861"/>
+          </a:xfrm>
+          <a:prstGeom prst="rect">
+            <a:avLst/>
+          </a:prstGeom>
+          <a:noFill/>
+        </p:spPr>
+        <p:txBody>
+          <a:bodyPr wrap="none" lIns="0" tIns="0" rIns="0" bIns="0" anchor="t">
+            <a:spAutoFit/>
+          </a:bodyPr>
+          <a:lstStyle/>
+          <a:p>
+            <a:pPr algn="l">
+              <a:lnSpc>
+                <a:spcPts val="2835"/>
+              </a:lnSpc>
+            </a:pPr>
+            <a:r>
+              <a:rPr lang="en-IN" sz="2100" b="1" i="0" u="none">
+                <a:solidFill>
+                  <a:srgbClr val="1E1B4B"/>
+                </a:solidFill>
+                <a:latin typeface="Montserrat"/>
+              </a:rPr>
+              <a:t>Campus Circ</a:t>
+            </a:r>
+            <a:r>
+              <a:rPr lang="en-IN" sz="2100" b="1">
+                <a:solidFill>
+                  <a:srgbClr val="1E1B4B"/>
+                </a:solidFill>
+                <a:latin typeface="Montserrat"/>
+              </a:rPr>
+              <a:t>le</a:t>
+            </a:r>
+            <a:endParaRPr sz="2100" b="1" i="0" u="none">
+              <a:solidFill>
+                <a:srgbClr val="1E1B4B"/>
+              </a:solidFill>
+              <a:latin typeface="Montserrat"/>
+            </a:endParaRPr>
+          </a:p>
+        </p:txBody>
+      </p:sp>
+      <p:sp>
+        <p:nvSpPr>
+          <p:cNvPr id="27" name="TextBox 26"/>
+          <p:cNvSpPr txBox="1"/>
+          <p:nvPr/>
+        </p:nvSpPr>
+        <p:spPr>
+          <a:xfrm>
+            <a:off x="781050" y="5257651"/>
+            <a:ext cx="6686550" cy="171450"/>
+          </a:xfrm>
+          <a:prstGeom prst="rect">
+            <a:avLst/>
+          </a:prstGeom>
+          <a:noFill/>
+        </p:spPr>
+        <p:txBody>
+          <a:bodyPr wrap="square" lIns="0" tIns="0" rIns="0" bIns="0" anchor="t">
+            <a:spAutoFit/>
+          </a:bodyPr>
+          <a:lstStyle/>
+          <a:p>
+            <a:pPr algn="l"/>
+            <a:r>
+              <a:rPr sz="900" b="1" i="0" u="none">
+                <a:solidFill>
+                  <a:srgbClr val="6B21A8"/>
+                </a:solidFill>
+                <a:latin typeface="Poppins"/>
+              </a:rPr>
+              <a:t>PRESENTED BY</a:t>
+            </a:r>
+          </a:p>
+        </p:txBody>
+      </p:sp>
+      <p:sp>
+        <p:nvSpPr>
+          <p:cNvPr id="28" name="TextBox 27"/>
+          <p:cNvSpPr txBox="1"/>
+          <p:nvPr/>
+        </p:nvSpPr>
+        <p:spPr>
+          <a:xfrm>
+            <a:off x="8115300" y="5376713"/>
+            <a:ext cx="3390900" cy="171450"/>
+          </a:xfrm>
+          <a:prstGeom prst="rect">
+            <a:avLst/>
+          </a:prstGeom>
+          <a:noFill/>
+        </p:spPr>
+        <p:txBody>
+          <a:bodyPr wrap="square" lIns="0" tIns="0" rIns="0" bIns="0" anchor="t">
+            <a:spAutoFit/>
+          </a:bodyPr>
+          <a:lstStyle/>
+          <a:p>
+            <a:pPr algn="l"/>
+            <a:r>
+              <a:rPr sz="900" b="1" i="0" u="none">
+                <a:solidFill>
+                  <a:srgbClr val="B45309"/>
+                </a:solidFill>
+                <a:latin typeface="Poppins"/>
+              </a:rPr>
+              <a:t>PROJECT GUIDE</a:t>
+            </a:r>
+          </a:p>
+        </p:txBody>
+      </p:sp>
+      <p:sp>
+        <p:nvSpPr>
+          <p:cNvPr id="29" name="TextBox 28"/>
+          <p:cNvSpPr txBox="1"/>
+          <p:nvPr/>
+        </p:nvSpPr>
+        <p:spPr>
+          <a:xfrm>
+            <a:off x="7881937" y="5767238"/>
+            <a:ext cx="3762375" cy="173124"/>
+          </a:xfrm>
+          <a:prstGeom prst="rect">
+            <a:avLst/>
+          </a:prstGeom>
+          <a:noFill/>
+        </p:spPr>
+        <p:txBody>
+          <a:bodyPr wrap="square" lIns="0" tIns="0" rIns="0" bIns="0" anchor="t">
+            <a:spAutoFit/>
+          </a:bodyPr>
+          <a:lstStyle/>
+          <a:p>
+            <a:pPr algn="ctr"/>
+            <a:r>
+              <a:rPr lang="en-IN" sz="1125" b="1">
+                <a:solidFill>
+                  <a:srgbClr val="78350F"/>
+                </a:solidFill>
+                <a:latin typeface="Poppins"/>
+              </a:rPr>
+              <a:t>Sijal</a:t>
+            </a:r>
+          </a:p>
+        </p:txBody>
+      </p:sp>
+      <p:sp>
+        <p:nvSpPr>
+          <p:cNvPr id="30" name="TextBox 29"/>
+          <p:cNvSpPr txBox="1"/>
+          <p:nvPr/>
+        </p:nvSpPr>
+        <p:spPr>
+          <a:xfrm>
+            <a:off x="681038" y="5819557"/>
+            <a:ext cx="1690687" cy="173124"/>
+          </a:xfrm>
+          <a:prstGeom prst="rect">
+            <a:avLst/>
+          </a:prstGeom>
+          <a:noFill/>
+        </p:spPr>
+        <p:txBody>
+          <a:bodyPr wrap="square" lIns="0" tIns="0" rIns="0" bIns="0" anchor="t">
+            <a:spAutoFit/>
+          </a:bodyPr>
+          <a:lstStyle/>
+          <a:p>
+            <a:pPr algn="ctr"/>
+            <a:r>
+              <a:rPr lang="en-IN" sz="1125" b="1" i="0" u="none">
+                <a:solidFill>
+                  <a:srgbClr val="3B0764"/>
+                </a:solidFill>
+                <a:latin typeface="Poppins"/>
+              </a:rPr>
+              <a:t>Abhilash R</a:t>
+            </a:r>
+            <a:endParaRPr sz="1125" b="1" i="0" u="none">
+              <a:solidFill>
+                <a:srgbClr val="3B0764"/>
+              </a:solidFill>
+              <a:latin typeface="Poppins"/>
+            </a:endParaRPr>
+          </a:p>
+        </p:txBody>
+      </p:sp>
+      <p:sp>
+        <p:nvSpPr>
+          <p:cNvPr id="31" name="TextBox 30"/>
+          <p:cNvSpPr txBox="1"/>
+          <p:nvPr/>
+        </p:nvSpPr>
+        <p:spPr>
+          <a:xfrm>
+            <a:off x="2402682" y="5813189"/>
+            <a:ext cx="1690687" cy="173124"/>
+          </a:xfrm>
+          <a:prstGeom prst="rect">
+            <a:avLst/>
+          </a:prstGeom>
+          <a:noFill/>
+        </p:spPr>
+        <p:txBody>
+          <a:bodyPr wrap="square" lIns="0" tIns="0" rIns="0" bIns="0" anchor="t">
+            <a:spAutoFit/>
+          </a:bodyPr>
+          <a:lstStyle/>
+          <a:p>
+            <a:pPr algn="ctr"/>
+            <a:r>
+              <a:rPr lang="en-IN" sz="1125" b="1" i="0" u="none">
+                <a:solidFill>
+                  <a:srgbClr val="3B0764"/>
+                </a:solidFill>
+                <a:latin typeface="Poppins"/>
+              </a:rPr>
+              <a:t>Anbu </a:t>
+            </a:r>
+            <a:r>
+              <a:rPr lang="en-IN" sz="1125" b="1">
+                <a:solidFill>
+                  <a:srgbClr val="3B0764"/>
+                </a:solidFill>
+                <a:latin typeface="Poppins"/>
+              </a:rPr>
+              <a:t>S</a:t>
+            </a:r>
+            <a:r>
+              <a:rPr lang="en-IN" sz="1125" b="1" i="0" u="none">
+                <a:solidFill>
+                  <a:srgbClr val="3B0764"/>
+                </a:solidFill>
+                <a:latin typeface="Poppins"/>
+              </a:rPr>
+              <a:t>elvan K</a:t>
+            </a:r>
+            <a:endParaRPr sz="1125" b="1" i="0" u="none">
+              <a:solidFill>
+                <a:srgbClr val="3B0764"/>
+              </a:solidFill>
+              <a:latin typeface="Poppins"/>
+            </a:endParaRPr>
+          </a:p>
+        </p:txBody>
+      </p:sp>
+      <p:sp>
+        <p:nvSpPr>
+          <p:cNvPr id="32" name="TextBox 31"/>
+          <p:cNvSpPr txBox="1"/>
+          <p:nvPr/>
+        </p:nvSpPr>
+        <p:spPr>
+          <a:xfrm>
+            <a:off x="4114800" y="5803664"/>
+            <a:ext cx="1690687" cy="173124"/>
+          </a:xfrm>
+          <a:prstGeom prst="rect">
+            <a:avLst/>
+          </a:prstGeom>
+          <a:noFill/>
+        </p:spPr>
+        <p:txBody>
+          <a:bodyPr wrap="square" lIns="0" tIns="0" rIns="0" bIns="0" anchor="t">
+            <a:spAutoFit/>
+          </a:bodyPr>
+          <a:lstStyle/>
+          <a:p>
+            <a:pPr algn="ctr"/>
+            <a:r>
+              <a:rPr lang="en-IN" sz="1125" b="1" i="0" u="none">
+                <a:solidFill>
+                  <a:srgbClr val="3B0764"/>
+                </a:solidFill>
+                <a:latin typeface="Poppins"/>
+              </a:rPr>
+              <a:t>Dileep Kumar A</a:t>
+            </a:r>
+            <a:endParaRPr sz="1125" b="1" i="0" u="none">
+              <a:solidFill>
+                <a:srgbClr val="3B0764"/>
+              </a:solidFill>
+              <a:latin typeface="Poppins"/>
+            </a:endParaRPr>
+          </a:p>
+        </p:txBody>
+      </p:sp>
+      <p:sp>
+        <p:nvSpPr>
+          <p:cNvPr id="33" name="TextBox 32"/>
+          <p:cNvSpPr txBox="1"/>
+          <p:nvPr/>
+        </p:nvSpPr>
+        <p:spPr>
+          <a:xfrm>
+            <a:off x="5738812" y="5813189"/>
+            <a:ext cx="1690687" cy="173124"/>
+          </a:xfrm>
+          <a:prstGeom prst="rect">
+            <a:avLst/>
+          </a:prstGeom>
+          <a:noFill/>
+        </p:spPr>
+        <p:txBody>
+          <a:bodyPr wrap="square" lIns="0" tIns="0" rIns="0" bIns="0" anchor="t">
+            <a:spAutoFit/>
+          </a:bodyPr>
+          <a:lstStyle/>
+          <a:p>
+            <a:pPr algn="ctr"/>
+            <a:r>
+              <a:rPr lang="en-IN" sz="1125" b="1" i="0" u="none" err="1">
+                <a:solidFill>
+                  <a:srgbClr val="3B0764"/>
+                </a:solidFill>
+                <a:latin typeface="Poppins"/>
+              </a:rPr>
+              <a:t>Aanandha</a:t>
+            </a:r>
+            <a:r>
+              <a:rPr lang="en-IN" sz="1125" b="1" i="0" u="none">
+                <a:solidFill>
+                  <a:srgbClr val="3B0764"/>
+                </a:solidFill>
+                <a:latin typeface="Poppins"/>
+              </a:rPr>
+              <a:t> S</a:t>
+            </a:r>
+            <a:endParaRPr sz="1125" b="1" i="0" u="none">
+              <a:solidFill>
+                <a:srgbClr val="3B0764"/>
+              </a:solidFill>
+              <a:latin typeface="Poppins"/>
+            </a:endParaRPr>
           </a:p>
         </p:txBody>
       </p:sp>
@@ -7616,7 +8667,7 @@
                 </a:solidFill>
                 <a:latin typeface="Calibri"/>
               </a:rPr>
-              <a:t>Built by Abhi Prajapathi  ·  October 2026</a:t>
+              <a:t>Department of Information Technology  ·  Er. Perumal Manimekalai College of Engineering</a:t>
             </a:r>
           </a:p>
         </p:txBody>
@@ -12346,7 +13397,7 @@
                 </a:solidFill>
                 <a:latin typeface="Calibri"/>
               </a:rPr>
-              <a:t>Fallback models: gemini-3.5-flash → gemini-flash-latest  |  Rate-limit resilience built in</a:t>
+              <a:t>Fallback models: gemini-2.5-flash → gemini-flash-latest  |  Rate-limit resilience built in</a:t>
             </a:r>
           </a:p>
         </p:txBody>
@@ -12711,7 +13762,7 @@
                 </a:solidFill>
                 <a:latin typeface="Georgia"/>
               </a:rPr>
-              <a:t>Aarav Sharma</a:t>
+              <a:t>Abhilash R</a:t>
             </a:r>
           </a:p>
         </p:txBody>

</xml_diff>

<commit_message>
feat: Admin event attendee roster view, CSV export, and updated PPT deck with Brevo & attendee features
</commit_message>
<xml_diff>
--- a/CampusCircle_Presentation.pptx
+++ b/CampusCircle_Presentation.pptx
@@ -4666,7 +4666,7 @@
                 </a:solidFill>
                 <a:latin typeface="Calibri"/>
               </a:rPr>
-              <a:t>Flask-powered backend routes</a:t>
+              <a:t>Flask backend routes &amp; attendee services</a:t>
             </a:r>
           </a:p>
         </p:txBody>
@@ -4801,7 +4801,7 @@
         <p:spPr>
           <a:xfrm>
             <a:off x="1298448" y="1481328"/>
-            <a:ext cx="4754880" cy="338328"/>
+            <a:ext cx="4937760" cy="338328"/>
           </a:xfrm>
           <a:prstGeom prst="rect">
             <a:avLst/>
@@ -4816,48 +4816,48 @@
           <a:p>
             <a:pPr algn="l"/>
             <a:r>
+              <a:rPr sz="1050" b="0" i="0">
+                <a:solidFill>
+                  <a:srgbClr val="CFE870"/>
+                </a:solidFill>
+                <a:latin typeface="Courier New"/>
+              </a:rPr>
+              <a:t>/api/events</a:t>
+            </a:r>
+          </a:p>
+        </p:txBody>
+      </p:sp>
+      <p:sp>
+        <p:nvSpPr>
+          <p:cNvPr id="10" name="TextBox 9"/>
+          <p:cNvSpPr txBox="1"/>
+          <p:nvPr/>
+        </p:nvSpPr>
+        <p:spPr>
+          <a:xfrm>
+            <a:off x="6309360" y="1481328"/>
+            <a:ext cx="5760720" cy="338328"/>
+          </a:xfrm>
+          <a:prstGeom prst="rect">
+            <a:avLst/>
+          </a:prstGeom>
+          <a:noFill/>
+        </p:spPr>
+        <p:txBody>
+          <a:bodyPr wrap="square">
+            <a:spAutoFit/>
+          </a:bodyPr>
+          <a:lstStyle/>
+          <a:p>
+            <a:pPr algn="l"/>
+            <a:r>
               <a:rPr sz="1100" b="0" i="0">
                 <a:solidFill>
-                  <a:srgbClr val="CFE870"/>
-                </a:solidFill>
-                <a:latin typeface="Courier New"/>
-              </a:rPr>
-              <a:t>/api/events</a:t>
-            </a:r>
-          </a:p>
-        </p:txBody>
-      </p:sp>
-      <p:sp>
-        <p:nvSpPr>
-          <p:cNvPr id="10" name="TextBox 9"/>
-          <p:cNvSpPr txBox="1"/>
-          <p:nvPr/>
-        </p:nvSpPr>
-        <p:spPr>
-          <a:xfrm>
-            <a:off x="6126480" y="1481328"/>
-            <a:ext cx="5943600" cy="338328"/>
-          </a:xfrm>
-          <a:prstGeom prst="rect">
-            <a:avLst/>
-          </a:prstGeom>
-          <a:noFill/>
-        </p:spPr>
-        <p:txBody>
-          <a:bodyPr wrap="square">
-            <a:spAutoFit/>
-          </a:bodyPr>
-          <a:lstStyle/>
-          <a:p>
-            <a:pPr algn="l"/>
-            <a:r>
-              <a:rPr sz="1100" b="0" i="0">
-                <a:solidFill>
                   <a:srgbClr val="FFFEFA"/>
                 </a:solidFill>
                 <a:latin typeface="Calibri"/>
               </a:rPr>
-              <a:t>List all events (with registration flag per user)</a:t>
+              <a:t>List all events with registration status per student</a:t>
             </a:r>
           </a:p>
         </p:txBody>
@@ -4992,7 +4992,7 @@
         <p:spPr>
           <a:xfrm>
             <a:off x="1298448" y="1975103"/>
-            <a:ext cx="4754880" cy="338328"/>
+            <a:ext cx="4937760" cy="338328"/>
           </a:xfrm>
           <a:prstGeom prst="rect">
             <a:avLst/>
@@ -5007,48 +5007,48 @@
           <a:p>
             <a:pPr algn="l"/>
             <a:r>
+              <a:rPr sz="1050" b="0" i="0">
+                <a:solidFill>
+                  <a:srgbClr val="CFE870"/>
+                </a:solidFill>
+                <a:latin typeface="Courier New"/>
+              </a:rPr>
+              <a:t>/api/events</a:t>
+            </a:r>
+          </a:p>
+        </p:txBody>
+      </p:sp>
+      <p:sp>
+        <p:nvSpPr>
+          <p:cNvPr id="15" name="TextBox 14"/>
+          <p:cNvSpPr txBox="1"/>
+          <p:nvPr/>
+        </p:nvSpPr>
+        <p:spPr>
+          <a:xfrm>
+            <a:off x="6309360" y="1975103"/>
+            <a:ext cx="5760720" cy="338328"/>
+          </a:xfrm>
+          <a:prstGeom prst="rect">
+            <a:avLst/>
+          </a:prstGeom>
+          <a:noFill/>
+        </p:spPr>
+        <p:txBody>
+          <a:bodyPr wrap="square">
+            <a:spAutoFit/>
+          </a:bodyPr>
+          <a:lstStyle/>
+          <a:p>
+            <a:pPr algn="l"/>
+            <a:r>
               <a:rPr sz="1100" b="0" i="0">
                 <a:solidFill>
-                  <a:srgbClr val="CFE870"/>
-                </a:solidFill>
-                <a:latin typeface="Courier New"/>
-              </a:rPr>
-              <a:t>/api/events</a:t>
-            </a:r>
-          </a:p>
-        </p:txBody>
-      </p:sp>
-      <p:sp>
-        <p:nvSpPr>
-          <p:cNvPr id="15" name="TextBox 14"/>
-          <p:cNvSpPr txBox="1"/>
-          <p:nvPr/>
-        </p:nvSpPr>
-        <p:spPr>
-          <a:xfrm>
-            <a:off x="6126480" y="1975103"/>
-            <a:ext cx="5943600" cy="338328"/>
-          </a:xfrm>
-          <a:prstGeom prst="rect">
-            <a:avLst/>
-          </a:prstGeom>
-          <a:noFill/>
-        </p:spPr>
-        <p:txBody>
-          <a:bodyPr wrap="square">
-            <a:spAutoFit/>
-          </a:bodyPr>
-          <a:lstStyle/>
-          <a:p>
-            <a:pPr algn="l"/>
-            <a:r>
-              <a:rPr sz="1100" b="0" i="0">
-                <a:solidFill>
                   <a:srgbClr val="FFFEFA"/>
                 </a:solidFill>
                 <a:latin typeface="Calibri"/>
               </a:rPr>
-              <a:t>Publish a new event (admin)</a:t>
+              <a:t>Publish new event to campus catalog (Admin)</a:t>
             </a:r>
           </a:p>
         </p:txBody>
@@ -5183,7 +5183,7 @@
         <p:spPr>
           <a:xfrm>
             <a:off x="1298448" y="2468879"/>
-            <a:ext cx="4754880" cy="338328"/>
+            <a:ext cx="4937760" cy="338328"/>
           </a:xfrm>
           <a:prstGeom prst="rect">
             <a:avLst/>
@@ -5198,48 +5198,48 @@
           <a:p>
             <a:pPr algn="l"/>
             <a:r>
+              <a:rPr sz="1050" b="0" i="0">
+                <a:solidFill>
+                  <a:srgbClr val="CFE870"/>
+                </a:solidFill>
+                <a:latin typeface="Courier New"/>
+              </a:rPr>
+              <a:t>/api/events/&lt;id&gt;</a:t>
+            </a:r>
+          </a:p>
+        </p:txBody>
+      </p:sp>
+      <p:sp>
+        <p:nvSpPr>
+          <p:cNvPr id="20" name="TextBox 19"/>
+          <p:cNvSpPr txBox="1"/>
+          <p:nvPr/>
+        </p:nvSpPr>
+        <p:spPr>
+          <a:xfrm>
+            <a:off x="6309360" y="2468879"/>
+            <a:ext cx="5760720" cy="338328"/>
+          </a:xfrm>
+          <a:prstGeom prst="rect">
+            <a:avLst/>
+          </a:prstGeom>
+          <a:noFill/>
+        </p:spPr>
+        <p:txBody>
+          <a:bodyPr wrap="square">
+            <a:spAutoFit/>
+          </a:bodyPr>
+          <a:lstStyle/>
+          <a:p>
+            <a:pPr algn="l"/>
+            <a:r>
               <a:rPr sz="1100" b="0" i="0">
                 <a:solidFill>
-                  <a:srgbClr val="CFE870"/>
-                </a:solidFill>
-                <a:latin typeface="Courier New"/>
-              </a:rPr>
-              <a:t>/api/events/&lt;id&gt;</a:t>
-            </a:r>
-          </a:p>
-        </p:txBody>
-      </p:sp>
-      <p:sp>
-        <p:nvSpPr>
-          <p:cNvPr id="20" name="TextBox 19"/>
-          <p:cNvSpPr txBox="1"/>
-          <p:nvPr/>
-        </p:nvSpPr>
-        <p:spPr>
-          <a:xfrm>
-            <a:off x="6126480" y="2468879"/>
-            <a:ext cx="5943600" cy="338328"/>
-          </a:xfrm>
-          <a:prstGeom prst="rect">
-            <a:avLst/>
-          </a:prstGeom>
-          <a:noFill/>
-        </p:spPr>
-        <p:txBody>
-          <a:bodyPr wrap="square">
-            <a:spAutoFit/>
-          </a:bodyPr>
-          <a:lstStyle/>
-          <a:p>
-            <a:pPr algn="l"/>
-            <a:r>
-              <a:rPr sz="1100" b="0" i="0">
-                <a:solidFill>
                   <a:srgbClr val="FFFEFA"/>
                 </a:solidFill>
                 <a:latin typeface="Calibri"/>
               </a:rPr>
-              <a:t>Delete an event and its registrations (admin)</a:t>
+              <a:t>Delete event with cascade registration cleanup (Admin)</a:t>
             </a:r>
           </a:p>
         </p:txBody>
@@ -5374,7 +5374,7 @@
         <p:spPr>
           <a:xfrm>
             <a:off x="1298448" y="2962656"/>
-            <a:ext cx="4754880" cy="338328"/>
+            <a:ext cx="4937760" cy="338328"/>
           </a:xfrm>
           <a:prstGeom prst="rect">
             <a:avLst/>
@@ -5389,48 +5389,48 @@
           <a:p>
             <a:pPr algn="l"/>
             <a:r>
+              <a:rPr sz="1050" b="0" i="0">
+                <a:solidFill>
+                  <a:srgbClr val="CFE870"/>
+                </a:solidFill>
+                <a:latin typeface="Courier New"/>
+              </a:rPr>
+              <a:t>/api/events/&lt;id&gt;/register</a:t>
+            </a:r>
+          </a:p>
+        </p:txBody>
+      </p:sp>
+      <p:sp>
+        <p:nvSpPr>
+          <p:cNvPr id="25" name="TextBox 24"/>
+          <p:cNvSpPr txBox="1"/>
+          <p:nvPr/>
+        </p:nvSpPr>
+        <p:spPr>
+          <a:xfrm>
+            <a:off x="6309360" y="2962656"/>
+            <a:ext cx="5760720" cy="338328"/>
+          </a:xfrm>
+          <a:prstGeom prst="rect">
+            <a:avLst/>
+          </a:prstGeom>
+          <a:noFill/>
+        </p:spPr>
+        <p:txBody>
+          <a:bodyPr wrap="square">
+            <a:spAutoFit/>
+          </a:bodyPr>
+          <a:lstStyle/>
+          <a:p>
+            <a:pPr algn="l"/>
+            <a:r>
               <a:rPr sz="1100" b="0" i="0">
                 <a:solidFill>
-                  <a:srgbClr val="CFE870"/>
-                </a:solidFill>
-                <a:latin typeface="Courier New"/>
-              </a:rPr>
-              <a:t>/api/events/&lt;id&gt;/register</a:t>
-            </a:r>
-          </a:p>
-        </p:txBody>
-      </p:sp>
-      <p:sp>
-        <p:nvSpPr>
-          <p:cNvPr id="25" name="TextBox 24"/>
-          <p:cNvSpPr txBox="1"/>
-          <p:nvPr/>
-        </p:nvSpPr>
-        <p:spPr>
-          <a:xfrm>
-            <a:off x="6126480" y="2962656"/>
-            <a:ext cx="5943600" cy="338328"/>
-          </a:xfrm>
-          <a:prstGeom prst="rect">
-            <a:avLst/>
-          </a:prstGeom>
-          <a:noFill/>
-        </p:spPr>
-        <p:txBody>
-          <a:bodyPr wrap="square">
-            <a:spAutoFit/>
-          </a:bodyPr>
-          <a:lstStyle/>
-          <a:p>
-            <a:pPr algn="l"/>
-            <a:r>
-              <a:rPr sz="1100" b="0" i="0">
-                <a:solidFill>
                   <a:srgbClr val="FFFEFA"/>
                 </a:solidFill>
                 <a:latin typeface="Calibri"/>
               </a:rPr>
-              <a:t>Register a student for an event</a:t>
+              <a:t>Register student + dispatch Brevo email pass</a:t>
             </a:r>
           </a:p>
         </p:txBody>
@@ -5493,7 +5493,7 @@
             <a:avLst/>
           </a:prstGeom>
           <a:solidFill>
-            <a:srgbClr val="1565C0"/>
+            <a:srgbClr val="2E7D32"/>
           </a:solidFill>
           <a:ln>
             <a:noFill/>
@@ -5551,7 +5551,7 @@
                 </a:solidFill>
                 <a:latin typeface="Calibri"/>
               </a:rPr>
-              <a:t>POST</a:t>
+              <a:t>GET</a:t>
             </a:r>
           </a:p>
         </p:txBody>
@@ -5565,7 +5565,7 @@
         <p:spPr>
           <a:xfrm>
             <a:off x="1298448" y="3456432"/>
-            <a:ext cx="4754880" cy="338328"/>
+            <a:ext cx="4937760" cy="338328"/>
           </a:xfrm>
           <a:prstGeom prst="rect">
             <a:avLst/>
@@ -5580,48 +5580,48 @@
           <a:p>
             <a:pPr algn="l"/>
             <a:r>
+              <a:rPr sz="1050" b="0" i="0">
+                <a:solidFill>
+                  <a:srgbClr val="CFE870"/>
+                </a:solidFill>
+                <a:latin typeface="Courier New"/>
+              </a:rPr>
+              <a:t>/api/events/&lt;id&gt;/registrations</a:t>
+            </a:r>
+          </a:p>
+        </p:txBody>
+      </p:sp>
+      <p:sp>
+        <p:nvSpPr>
+          <p:cNvPr id="30" name="TextBox 29"/>
+          <p:cNvSpPr txBox="1"/>
+          <p:nvPr/>
+        </p:nvSpPr>
+        <p:spPr>
+          <a:xfrm>
+            <a:off x="6309360" y="3456432"/>
+            <a:ext cx="5760720" cy="338328"/>
+          </a:xfrm>
+          <a:prstGeom prst="rect">
+            <a:avLst/>
+          </a:prstGeom>
+          <a:noFill/>
+        </p:spPr>
+        <p:txBody>
+          <a:bodyPr wrap="square">
+            <a:spAutoFit/>
+          </a:bodyPr>
+          <a:lstStyle/>
+          <a:p>
+            <a:pPr algn="l"/>
+            <a:r>
               <a:rPr sz="1100" b="0" i="0">
                 <a:solidFill>
-                  <a:srgbClr val="CFE870"/>
-                </a:solidFill>
-                <a:latin typeface="Courier New"/>
-              </a:rPr>
-              <a:t>/api/login</a:t>
-            </a:r>
-          </a:p>
-        </p:txBody>
-      </p:sp>
-      <p:sp>
-        <p:nvSpPr>
-          <p:cNvPr id="30" name="TextBox 29"/>
-          <p:cNvSpPr txBox="1"/>
-          <p:nvPr/>
-        </p:nvSpPr>
-        <p:spPr>
-          <a:xfrm>
-            <a:off x="6126480" y="3456432"/>
-            <a:ext cx="5943600" cy="338328"/>
-          </a:xfrm>
-          <a:prstGeom prst="rect">
-            <a:avLst/>
-          </a:prstGeom>
-          <a:noFill/>
-        </p:spPr>
-        <p:txBody>
-          <a:bodyPr wrap="square">
-            <a:spAutoFit/>
-          </a:bodyPr>
-          <a:lstStyle/>
-          <a:p>
-            <a:pPr algn="l"/>
-            <a:r>
-              <a:rPr sz="1100" b="0" i="0">
-                <a:solidFill>
                   <a:srgbClr val="FFFEFA"/>
                 </a:solidFill>
                 <a:latin typeface="Calibri"/>
               </a:rPr>
-              <a:t>Authenticate a user, return profile JSON</a:t>
+              <a:t>Fetch attendee roster (names, reg_no, dept) for admin</a:t>
             </a:r>
           </a:p>
         </p:txBody>
@@ -5756,7 +5756,7 @@
         <p:spPr>
           <a:xfrm>
             <a:off x="1298448" y="3950208"/>
-            <a:ext cx="4754880" cy="338328"/>
+            <a:ext cx="4937760" cy="338328"/>
           </a:xfrm>
           <a:prstGeom prst="rect">
             <a:avLst/>
@@ -5771,48 +5771,48 @@
           <a:p>
             <a:pPr algn="l"/>
             <a:r>
+              <a:rPr sz="1050" b="0" i="0">
+                <a:solidFill>
+                  <a:srgbClr val="CFE870"/>
+                </a:solidFill>
+                <a:latin typeface="Courier New"/>
+              </a:rPr>
+              <a:t>/api/register-user</a:t>
+            </a:r>
+          </a:p>
+        </p:txBody>
+      </p:sp>
+      <p:sp>
+        <p:nvSpPr>
+          <p:cNvPr id="35" name="TextBox 34"/>
+          <p:cNvSpPr txBox="1"/>
+          <p:nvPr/>
+        </p:nvSpPr>
+        <p:spPr>
+          <a:xfrm>
+            <a:off x="6309360" y="3950208"/>
+            <a:ext cx="5760720" cy="338328"/>
+          </a:xfrm>
+          <a:prstGeom prst="rect">
+            <a:avLst/>
+          </a:prstGeom>
+          <a:noFill/>
+        </p:spPr>
+        <p:txBody>
+          <a:bodyPr wrap="square">
+            <a:spAutoFit/>
+          </a:bodyPr>
+          <a:lstStyle/>
+          <a:p>
+            <a:pPr algn="l"/>
+            <a:r>
               <a:rPr sz="1100" b="0" i="0">
                 <a:solidFill>
-                  <a:srgbClr val="CFE870"/>
-                </a:solidFill>
-                <a:latin typeface="Courier New"/>
-              </a:rPr>
-              <a:t>/api/register-user</a:t>
-            </a:r>
-          </a:p>
-        </p:txBody>
-      </p:sp>
-      <p:sp>
-        <p:nvSpPr>
-          <p:cNvPr id="35" name="TextBox 34"/>
-          <p:cNvSpPr txBox="1"/>
-          <p:nvPr/>
-        </p:nvSpPr>
-        <p:spPr>
-          <a:xfrm>
-            <a:off x="6126480" y="3950208"/>
-            <a:ext cx="5943600" cy="338328"/>
-          </a:xfrm>
-          <a:prstGeom prst="rect">
-            <a:avLst/>
-          </a:prstGeom>
-          <a:noFill/>
-        </p:spPr>
-        <p:txBody>
-          <a:bodyPr wrap="square">
-            <a:spAutoFit/>
-          </a:bodyPr>
-          <a:lstStyle/>
-          <a:p>
-            <a:pPr algn="l"/>
-            <a:r>
-              <a:rPr sz="1100" b="0" i="0">
-                <a:solidFill>
                   <a:srgbClr val="FFFEFA"/>
                 </a:solidFill>
                 <a:latin typeface="Calibri"/>
               </a:rPr>
-              <a:t>Create a new student account</a:t>
+              <a:t>Create student account + dispatch Brevo welcome email</a:t>
             </a:r>
           </a:p>
         </p:txBody>
@@ -5875,7 +5875,7 @@
             <a:avLst/>
           </a:prstGeom>
           <a:solidFill>
-            <a:srgbClr val="2E7D32"/>
+            <a:srgbClr val="1565C0"/>
           </a:solidFill>
           <a:ln>
             <a:noFill/>
@@ -5933,7 +5933,7 @@
                 </a:solidFill>
                 <a:latin typeface="Calibri"/>
               </a:rPr>
-              <a:t>GET</a:t>
+              <a:t>POST</a:t>
             </a:r>
           </a:p>
         </p:txBody>
@@ -5947,7 +5947,7 @@
         <p:spPr>
           <a:xfrm>
             <a:off x="1298448" y="4443984"/>
-            <a:ext cx="4754880" cy="338328"/>
+            <a:ext cx="4937760" cy="338328"/>
           </a:xfrm>
           <a:prstGeom prst="rect">
             <a:avLst/>
@@ -5962,48 +5962,48 @@
           <a:p>
             <a:pPr algn="l"/>
             <a:r>
+              <a:rPr sz="1050" b="0" i="0">
+                <a:solidFill>
+                  <a:srgbClr val="CFE870"/>
+                </a:solidFill>
+                <a:latin typeface="Courier New"/>
+              </a:rPr>
+              <a:t>/api/login</a:t>
+            </a:r>
+          </a:p>
+        </p:txBody>
+      </p:sp>
+      <p:sp>
+        <p:nvSpPr>
+          <p:cNvPr id="40" name="TextBox 39"/>
+          <p:cNvSpPr txBox="1"/>
+          <p:nvPr/>
+        </p:nvSpPr>
+        <p:spPr>
+          <a:xfrm>
+            <a:off x="6309360" y="4443984"/>
+            <a:ext cx="5760720" cy="338328"/>
+          </a:xfrm>
+          <a:prstGeom prst="rect">
+            <a:avLst/>
+          </a:prstGeom>
+          <a:noFill/>
+        </p:spPr>
+        <p:txBody>
+          <a:bodyPr wrap="square">
+            <a:spAutoFit/>
+          </a:bodyPr>
+          <a:lstStyle/>
+          <a:p>
+            <a:pPr algn="l"/>
+            <a:r>
               <a:rPr sz="1100" b="0" i="0">
                 <a:solidFill>
-                  <a:srgbClr val="CFE870"/>
-                </a:solidFill>
-                <a:latin typeface="Courier New"/>
-              </a:rPr>
-              <a:t>/api/me/&lt;user_id&gt;</a:t>
-            </a:r>
-          </a:p>
-        </p:txBody>
-      </p:sp>
-      <p:sp>
-        <p:nvSpPr>
-          <p:cNvPr id="40" name="TextBox 39"/>
-          <p:cNvSpPr txBox="1"/>
-          <p:nvPr/>
-        </p:nvSpPr>
-        <p:spPr>
-          <a:xfrm>
-            <a:off x="6126480" y="4443984"/>
-            <a:ext cx="5943600" cy="338328"/>
-          </a:xfrm>
-          <a:prstGeom prst="rect">
-            <a:avLst/>
-          </a:prstGeom>
-          <a:noFill/>
-        </p:spPr>
-        <p:txBody>
-          <a:bodyPr wrap="square">
-            <a:spAutoFit/>
-          </a:bodyPr>
-          <a:lstStyle/>
-          <a:p>
-            <a:pPr algn="l"/>
-            <a:r>
-              <a:rPr sz="1100" b="0" i="0">
-                <a:solidFill>
                   <a:srgbClr val="FFFEFA"/>
                 </a:solidFill>
                 <a:latin typeface="Calibri"/>
               </a:rPr>
-              <a:t>Fetch live user profile from DB</a:t>
+              <a:t>Authenticate student/admin &amp; return profile</a:t>
             </a:r>
           </a:p>
         </p:txBody>
@@ -6138,7 +6138,7 @@
         <p:spPr>
           <a:xfrm>
             <a:off x="1298448" y="4937760"/>
-            <a:ext cx="4754880" cy="338328"/>
+            <a:ext cx="4937760" cy="338328"/>
           </a:xfrm>
           <a:prstGeom prst="rect">
             <a:avLst/>
@@ -6153,48 +6153,48 @@
           <a:p>
             <a:pPr algn="l"/>
             <a:r>
+              <a:rPr sz="1050" b="0" i="0">
+                <a:solidFill>
+                  <a:srgbClr val="CFE870"/>
+                </a:solidFill>
+                <a:latin typeface="Courier New"/>
+              </a:rPr>
+              <a:t>/api/registrations/&lt;user_id&gt;</a:t>
+            </a:r>
+          </a:p>
+        </p:txBody>
+      </p:sp>
+      <p:sp>
+        <p:nvSpPr>
+          <p:cNvPr id="45" name="TextBox 44"/>
+          <p:cNvSpPr txBox="1"/>
+          <p:nvPr/>
+        </p:nvSpPr>
+        <p:spPr>
+          <a:xfrm>
+            <a:off x="6309360" y="4937760"/>
+            <a:ext cx="5760720" cy="338328"/>
+          </a:xfrm>
+          <a:prstGeom prst="rect">
+            <a:avLst/>
+          </a:prstGeom>
+          <a:noFill/>
+        </p:spPr>
+        <p:txBody>
+          <a:bodyPr wrap="square">
+            <a:spAutoFit/>
+          </a:bodyPr>
+          <a:lstStyle/>
+          <a:p>
+            <a:pPr algn="l"/>
+            <a:r>
               <a:rPr sz="1100" b="0" i="0">
                 <a:solidFill>
-                  <a:srgbClr val="CFE870"/>
-                </a:solidFill>
-                <a:latin typeface="Courier New"/>
-              </a:rPr>
-              <a:t>/api/registrations/&lt;user_id&gt;</a:t>
-            </a:r>
-          </a:p>
-        </p:txBody>
-      </p:sp>
-      <p:sp>
-        <p:nvSpPr>
-          <p:cNvPr id="45" name="TextBox 44"/>
-          <p:cNvSpPr txBox="1"/>
-          <p:nvPr/>
-        </p:nvSpPr>
-        <p:spPr>
-          <a:xfrm>
-            <a:off x="6126480" y="4937760"/>
-            <a:ext cx="5943600" cy="338328"/>
-          </a:xfrm>
-          <a:prstGeom prst="rect">
-            <a:avLst/>
-          </a:prstGeom>
-          <a:noFill/>
-        </p:spPr>
-        <p:txBody>
-          <a:bodyPr wrap="square">
-            <a:spAutoFit/>
-          </a:bodyPr>
-          <a:lstStyle/>
-          <a:p>
-            <a:pPr algn="l"/>
-            <a:r>
-              <a:rPr sz="1100" b="0" i="0">
-                <a:solidFill>
                   <a:srgbClr val="FFFEFA"/>
                 </a:solidFill>
                 <a:latin typeface="Calibri"/>
               </a:rPr>
-              <a:t>List all events registered by a student</a:t>
+              <a:t>Fetch events registered by a student for certificates</a:t>
             </a:r>
           </a:p>
         </p:txBody>
@@ -6329,7 +6329,7 @@
         <p:spPr>
           <a:xfrm>
             <a:off x="1298448" y="5431536"/>
-            <a:ext cx="4754880" cy="338328"/>
+            <a:ext cx="4937760" cy="338328"/>
           </a:xfrm>
           <a:prstGeom prst="rect">
             <a:avLst/>
@@ -6344,48 +6344,48 @@
           <a:p>
             <a:pPr algn="l"/>
             <a:r>
+              <a:rPr sz="1050" b="0" i="0">
+                <a:solidFill>
+                  <a:srgbClr val="CFE870"/>
+                </a:solidFill>
+                <a:latin typeface="Courier New"/>
+              </a:rPr>
+              <a:t>/api/recommendations/&lt;user_id&gt;</a:t>
+            </a:r>
+          </a:p>
+        </p:txBody>
+      </p:sp>
+      <p:sp>
+        <p:nvSpPr>
+          <p:cNvPr id="50" name="TextBox 49"/>
+          <p:cNvSpPr txBox="1"/>
+          <p:nvPr/>
+        </p:nvSpPr>
+        <p:spPr>
+          <a:xfrm>
+            <a:off x="6309360" y="5431536"/>
+            <a:ext cx="5760720" cy="338328"/>
+          </a:xfrm>
+          <a:prstGeom prst="rect">
+            <a:avLst/>
+          </a:prstGeom>
+          <a:noFill/>
+        </p:spPr>
+        <p:txBody>
+          <a:bodyPr wrap="square">
+            <a:spAutoFit/>
+          </a:bodyPr>
+          <a:lstStyle/>
+          <a:p>
+            <a:pPr algn="l"/>
+            <a:r>
               <a:rPr sz="1100" b="0" i="0">
                 <a:solidFill>
-                  <a:srgbClr val="CFE870"/>
-                </a:solidFill>
-                <a:latin typeface="Courier New"/>
-              </a:rPr>
-              <a:t>/api/recommendations/&lt;user_id&gt;</a:t>
-            </a:r>
-          </a:p>
-        </p:txBody>
-      </p:sp>
-      <p:sp>
-        <p:nvSpPr>
-          <p:cNvPr id="50" name="TextBox 49"/>
-          <p:cNvSpPr txBox="1"/>
-          <p:nvPr/>
-        </p:nvSpPr>
-        <p:spPr>
-          <a:xfrm>
-            <a:off x="6126480" y="5431536"/>
-            <a:ext cx="5943600" cy="338328"/>
-          </a:xfrm>
-          <a:prstGeom prst="rect">
-            <a:avLst/>
-          </a:prstGeom>
-          <a:noFill/>
-        </p:spPr>
-        <p:txBody>
-          <a:bodyPr wrap="square">
-            <a:spAutoFit/>
-          </a:bodyPr>
-          <a:lstStyle/>
-          <a:p>
-            <a:pPr algn="l"/>
-            <a:r>
-              <a:rPr sz="1100" b="0" i="0">
-                <a:solidFill>
                   <a:srgbClr val="FFFEFA"/>
                 </a:solidFill>
                 <a:latin typeface="Calibri"/>
               </a:rPr>
-              <a:t>Get AI-scored event recommendations</a:t>
+              <a:t>Get interest-weighted event recommendations</a:t>
             </a:r>
           </a:p>
         </p:txBody>
@@ -6520,7 +6520,7 @@
         <p:spPr>
           <a:xfrm>
             <a:off x="1298448" y="5925312"/>
-            <a:ext cx="4754880" cy="338328"/>
+            <a:ext cx="4937760" cy="338328"/>
           </a:xfrm>
           <a:prstGeom prst="rect">
             <a:avLst/>
@@ -6535,48 +6535,48 @@
           <a:p>
             <a:pPr algn="l"/>
             <a:r>
+              <a:rPr sz="1050" b="0" i="0">
+                <a:solidFill>
+                  <a:srgbClr val="CFE870"/>
+                </a:solidFill>
+                <a:latin typeface="Courier New"/>
+              </a:rPr>
+              <a:t>/api/admin/stats</a:t>
+            </a:r>
+          </a:p>
+        </p:txBody>
+      </p:sp>
+      <p:sp>
+        <p:nvSpPr>
+          <p:cNvPr id="55" name="TextBox 54"/>
+          <p:cNvSpPr txBox="1"/>
+          <p:nvPr/>
+        </p:nvSpPr>
+        <p:spPr>
+          <a:xfrm>
+            <a:off x="6309360" y="5925312"/>
+            <a:ext cx="5760720" cy="338328"/>
+          </a:xfrm>
+          <a:prstGeom prst="rect">
+            <a:avLst/>
+          </a:prstGeom>
+          <a:noFill/>
+        </p:spPr>
+        <p:txBody>
+          <a:bodyPr wrap="square">
+            <a:spAutoFit/>
+          </a:bodyPr>
+          <a:lstStyle/>
+          <a:p>
+            <a:pPr algn="l"/>
+            <a:r>
               <a:rPr sz="1100" b="0" i="0">
                 <a:solidFill>
-                  <a:srgbClr val="CFE870"/>
-                </a:solidFill>
-                <a:latin typeface="Courier New"/>
-              </a:rPr>
-              <a:t>/api/admin/stats</a:t>
-            </a:r>
-          </a:p>
-        </p:txBody>
-      </p:sp>
-      <p:sp>
-        <p:nvSpPr>
-          <p:cNvPr id="55" name="TextBox 54"/>
-          <p:cNvSpPr txBox="1"/>
-          <p:nvPr/>
-        </p:nvSpPr>
-        <p:spPr>
-          <a:xfrm>
-            <a:off x="6126480" y="5925312"/>
-            <a:ext cx="5943600" cy="338328"/>
-          </a:xfrm>
-          <a:prstGeom prst="rect">
-            <a:avLst/>
-          </a:prstGeom>
-          <a:noFill/>
-        </p:spPr>
-        <p:txBody>
-          <a:bodyPr wrap="square">
-            <a:spAutoFit/>
-          </a:bodyPr>
-          <a:lstStyle/>
-          <a:p>
-            <a:pPr algn="l"/>
-            <a:r>
-              <a:rPr sz="1100" b="0" i="0">
-                <a:solidFill>
                   <a:srgbClr val="FFFEFA"/>
                 </a:solidFill>
                 <a:latin typeface="Calibri"/>
               </a:rPr>
-              <a:t>Live dashboard counters (events, reg, students)</a:t>
+              <a:t>Live dashboard metrics (events, reg, students)</a:t>
             </a:r>
           </a:p>
         </p:txBody>
@@ -6711,7 +6711,7 @@
         <p:spPr>
           <a:xfrm>
             <a:off x="1298448" y="6419088"/>
-            <a:ext cx="4754880" cy="338328"/>
+            <a:ext cx="4937760" cy="338328"/>
           </a:xfrm>
           <a:prstGeom prst="rect">
             <a:avLst/>
@@ -6726,48 +6726,48 @@
           <a:p>
             <a:pPr algn="l"/>
             <a:r>
+              <a:rPr sz="1050" b="0" i="0">
+                <a:solidFill>
+                  <a:srgbClr val="CFE870"/>
+                </a:solidFill>
+                <a:latin typeface="Courier New"/>
+              </a:rPr>
+              <a:t>/api/ai/generate-event</a:t>
+            </a:r>
+          </a:p>
+        </p:txBody>
+      </p:sp>
+      <p:sp>
+        <p:nvSpPr>
+          <p:cNvPr id="60" name="TextBox 59"/>
+          <p:cNvSpPr txBox="1"/>
+          <p:nvPr/>
+        </p:nvSpPr>
+        <p:spPr>
+          <a:xfrm>
+            <a:off x="6309360" y="6419088"/>
+            <a:ext cx="5760720" cy="338328"/>
+          </a:xfrm>
+          <a:prstGeom prst="rect">
+            <a:avLst/>
+          </a:prstGeom>
+          <a:noFill/>
+        </p:spPr>
+        <p:txBody>
+          <a:bodyPr wrap="square">
+            <a:spAutoFit/>
+          </a:bodyPr>
+          <a:lstStyle/>
+          <a:p>
+            <a:pPr algn="l"/>
+            <a:r>
               <a:rPr sz="1100" b="0" i="0">
                 <a:solidFill>
-                  <a:srgbClr val="CFE870"/>
-                </a:solidFill>
-                <a:latin typeface="Courier New"/>
-              </a:rPr>
-              <a:t>/api/ai/generate-event</a:t>
-            </a:r>
-          </a:p>
-        </p:txBody>
-      </p:sp>
-      <p:sp>
-        <p:nvSpPr>
-          <p:cNvPr id="60" name="TextBox 59"/>
-          <p:cNvSpPr txBox="1"/>
-          <p:nvPr/>
-        </p:nvSpPr>
-        <p:spPr>
-          <a:xfrm>
-            <a:off x="6126480" y="6419088"/>
-            <a:ext cx="5943600" cy="338328"/>
-          </a:xfrm>
-          <a:prstGeom prst="rect">
-            <a:avLst/>
-          </a:prstGeom>
-          <a:noFill/>
-        </p:spPr>
-        <p:txBody>
-          <a:bodyPr wrap="square">
-            <a:spAutoFit/>
-          </a:bodyPr>
-          <a:lstStyle/>
-          <a:p>
-            <a:pPr algn="l"/>
-            <a:r>
-              <a:rPr sz="1100" b="0" i="0">
-                <a:solidFill>
                   <a:srgbClr val="FFFEFA"/>
                 </a:solidFill>
                 <a:latin typeface="Calibri"/>
               </a:rPr>
-              <a:t>Gemini AI: generate event JSON from a prompt</a:t>
+              <a:t>Gemini AI: generate full event JSON from rough prompt</a:t>
             </a:r>
           </a:p>
         </p:txBody>
@@ -6941,7 +6941,7 @@
                 </a:solidFill>
                 <a:latin typeface="Calibri"/>
               </a:rPr>
-              <a:t>From local dev to production</a:t>
+              <a:t>From local dev to cloud production</a:t>
             </a:r>
           </a:p>
         </p:txBody>
@@ -7013,7 +7013,7 @@
           <a:p>
             <a:pPr algn="l"/>
             <a:r>
-              <a:rPr sz="1500" b="1">
+              <a:rPr sz="1450" b="1">
                 <a:solidFill>
                   <a:srgbClr val="CFE870"/>
                 </a:solidFill>
@@ -7029,13 +7029,13 @@
               </a:spcBef>
             </a:pPr>
             <a:r>
-              <a:rPr sz="1400">
+              <a:rPr sz="1350">
                 <a:solidFill>
                   <a:srgbClr val="FFFEFA"/>
                 </a:solidFill>
                 <a:latin typeface="Calibri"/>
               </a:rPr>
-              <a:t>• 📦  Clone the repo from GitHub</a:t>
+              <a:t>• 📦  Clone repository from GitHub</a:t>
             </a:r>
           </a:p>
           <a:p>
@@ -7045,7 +7045,7 @@
               </a:spcBef>
             </a:pPr>
             <a:r>
-              <a:rPr sz="1400">
+              <a:rPr sz="1350">
                 <a:solidFill>
                   <a:srgbClr val="FFFEFA"/>
                 </a:solidFill>
@@ -7061,13 +7061,13 @@
               </a:spcBef>
             </a:pPr>
             <a:r>
-              <a:rPr sz="1400">
+              <a:rPr sz="1350">
                 <a:solidFill>
                   <a:srgbClr val="FFFEFA"/>
                 </a:solidFill>
                 <a:latin typeface="Calibri"/>
               </a:rPr>
-              <a:t>• 📝  Create backend/.env with DATABASE_URL &amp; GEMINI_API_KEY</a:t>
+              <a:t>• 📝  Configure backend/.env with DATABASE_URL, GEMINI_API_KEY, BREVO_API_KEY</a:t>
             </a:r>
           </a:p>
           <a:p>
@@ -7077,7 +7077,7 @@
               </a:spcBef>
             </a:pPr>
             <a:r>
-              <a:rPr sz="1400">
+              <a:rPr sz="1350">
                 <a:solidFill>
                   <a:srgbClr val="FFFEFA"/>
                 </a:solidFill>
@@ -7093,7 +7093,7 @@
               </a:spcBef>
             </a:pPr>
             <a:r>
-              <a:rPr sz="1400">
+              <a:rPr sz="1350">
                 <a:solidFill>
                   <a:srgbClr val="FFFEFA"/>
                 </a:solidFill>
@@ -7109,7 +7109,7 @@
               </a:spcBef>
             </a:pPr>
             <a:r>
-              <a:rPr sz="1400">
+              <a:rPr sz="1350">
                 <a:solidFill>
                   <a:srgbClr val="FFFEFA"/>
                 </a:solidFill>
@@ -7125,13 +7125,13 @@
               </a:spcBef>
             </a:pPr>
             <a:r>
-              <a:rPr sz="1400">
+              <a:rPr sz="1350">
                 <a:solidFill>
                   <a:srgbClr val="FFFEFA"/>
                 </a:solidFill>
                 <a:latin typeface="Calibri"/>
               </a:rPr>
-              <a:t>• 🌐  All /api/* calls proxy to Flask via vite.config.js</a:t>
+              <a:t>• 🌐  Vite proxies /api/* calls to Flask during local dev</a:t>
             </a:r>
           </a:p>
         </p:txBody>
@@ -7203,7 +7203,7 @@
           <a:p>
             <a:pPr algn="l"/>
             <a:r>
-              <a:rPr sz="1500" b="1">
+              <a:rPr sz="1450" b="1">
                 <a:solidFill>
                   <a:srgbClr val="CFE870"/>
                 </a:solidFill>
@@ -7219,7 +7219,7 @@
               </a:spcBef>
             </a:pPr>
             <a:r>
-              <a:rPr sz="1400">
+              <a:rPr sz="1350">
                 <a:solidFill>
                   <a:srgbClr val="FFFEFA"/>
                 </a:solidFill>
@@ -7235,13 +7235,13 @@
               </a:spcBef>
             </a:pPr>
             <a:r>
-              <a:rPr sz="1400">
+              <a:rPr sz="1350">
                 <a:solidFill>
                   <a:srgbClr val="FFFEFA"/>
                 </a:solidFill>
                 <a:latin typeface="Calibri"/>
               </a:rPr>
-              <a:t>• ☁  Vercel auto-deploys the frontend</a:t>
+              <a:t>• ☁  Vercel automatically deploys frontend &amp; backend</a:t>
             </a:r>
           </a:p>
           <a:p>
@@ -7251,13 +7251,13 @@
               </a:spcBef>
             </a:pPr>
             <a:r>
-              <a:rPr sz="1400">
+              <a:rPr sz="1350">
                 <a:solidFill>
                   <a:srgbClr val="FFFEFA"/>
                 </a:solidFill>
                 <a:latin typeface="Calibri"/>
               </a:rPr>
-              <a:t>• 🔑  Add ENV vars in Vercel dashboard:</a:t>
+              <a:t>• 🔑  Environment variables in Vercel settings:</a:t>
             </a:r>
           </a:p>
           <a:p>
@@ -7267,7 +7267,7 @@
               </a:spcBef>
             </a:pPr>
             <a:r>
-              <a:rPr sz="1400">
+              <a:rPr sz="1350">
                 <a:solidFill>
                   <a:srgbClr val="FFFEFA"/>
                 </a:solidFill>
@@ -7283,7 +7283,7 @@
               </a:spcBef>
             </a:pPr>
             <a:r>
-              <a:rPr sz="1400">
+              <a:rPr sz="1350">
                 <a:solidFill>
                   <a:srgbClr val="FFFEFA"/>
                 </a:solidFill>
@@ -7299,13 +7299,13 @@
               </a:spcBef>
             </a:pPr>
             <a:r>
-              <a:rPr sz="1400">
+              <a:rPr sz="1350">
                 <a:solidFill>
                   <a:srgbClr val="FFFEFA"/>
                 </a:solidFill>
                 <a:latin typeface="Calibri"/>
               </a:rPr>
-              <a:t>• 🗄  Database hosted on Neon PostgreSQL</a:t>
+              <a:t>•       BREVO_API_KEY=xkeysib-...</a:t>
             </a:r>
           </a:p>
           <a:p>
@@ -7315,13 +7315,29 @@
               </a:spcBef>
             </a:pPr>
             <a:r>
-              <a:rPr sz="1400">
+              <a:rPr sz="1350">
                 <a:solidFill>
                   <a:srgbClr val="FFFEFA"/>
                 </a:solidFill>
                 <a:latin typeface="Calibri"/>
               </a:rPr>
-              <a:t>•       (No server to manage!)</a:t>
+              <a:t>•       BREVO_SENDER_EMAIL=campus.circle.edu@gmail.com</a:t>
+            </a:r>
+          </a:p>
+          <a:p>
+            <a:pPr algn="l">
+              <a:spcBef>
+                <a:spcPts val="400"/>
+              </a:spcBef>
+            </a:pPr>
+            <a:r>
+              <a:rPr sz="1350">
+                <a:solidFill>
+                  <a:srgbClr val="FFFEFA"/>
+                </a:solidFill>
+                <a:latin typeface="Calibri"/>
+              </a:rPr>
+              <a:t>• 🗄  PostgreSQL hosted on Neon serverless cloud</a:t>
             </a:r>
           </a:p>
         </p:txBody>
@@ -7885,7 +7901,7 @@
                 </a:solidFill>
                 <a:latin typeface="Calibri"/>
               </a:rPr>
-              <a:t>Certificates</a:t>
+              <a:t>Brevo Email</a:t>
             </a:r>
           </a:p>
         </p:txBody>
@@ -7963,7 +7979,7 @@
                 </a:solidFill>
                 <a:latin typeface="Calibri"/>
               </a:rPr>
-              <a:t>Admin Dashboard</a:t>
+              <a:t>Attendee Rosters</a:t>
             </a:r>
           </a:p>
         </p:txBody>
@@ -8250,7 +8266,7 @@
                 </a:solidFill>
                 <a:latin typeface="Calibri"/>
               </a:rPr>
-              <a:t>Campus Circle is a full-stack college event management platform designed to bridge the gap between event organizers and students. It provides a single, elegant interface for publishing, discovering, and registering for campus events.</a:t>
+              <a:t>Campus Circle is a modern full-stack college event management platform designed to bridge the gap between event organizers and students. It provides a centralized, responsive interface for publishing events, managing student rosters, automated email ticketing, and digital certifications.</a:t>
             </a:r>
           </a:p>
         </p:txBody>
@@ -8363,7 +8379,7 @@
                 </a:solidFill>
                 <a:latin typeface="Calibri"/>
               </a:rPr>
-              <a:t>Students miss events due to scattered announcements across WhatsApp, notice boards, and email chains.</a:t>
+              <a:t>Students miss events due to fragmented notices on WhatsApp and notice boards. Admins lack real-time attendee visibility.</a:t>
             </a:r>
           </a:p>
         </p:txBody>
@@ -8476,7 +8492,7 @@
                 </a:solidFill>
                 <a:latin typeface="Calibri"/>
               </a:rPr>
-              <a:t>A centralized platform where admins publish events and students discover &amp; register in one place.</a:t>
+              <a:t>Centralized platform where admins publish events, track student rosters, and send automated Brevo email passes.</a:t>
             </a:r>
           </a:p>
         </p:txBody>
@@ -8589,7 +8605,7 @@
                 </a:solidFill>
                 <a:latin typeface="Calibri"/>
               </a:rPr>
-              <a:t>Hosted on Vercel (frontend) with a Neon PostgreSQL cloud database for persistent data.</a:t>
+              <a:t>Hosted on Vercel with Neon PostgreSQL serverless cloud DB, Brevo transactional email, and Gemini AI integration.</a:t>
             </a:r>
           </a:p>
         </p:txBody>
@@ -9040,7 +9056,7 @@
                 </a:solidFill>
                 <a:latin typeface="Calibri"/>
               </a:rPr>
-              <a:t>Frontend UI framework with blazing-fast HMR and component-based architecture.</a:t>
+              <a:t>Frontend UI framework with mobile-responsive layouts, fast HMR, and smooth modal flows.</a:t>
             </a:r>
           </a:p>
         </p:txBody>
@@ -9196,7 +9212,7 @@
                 </a:solidFill>
                 <a:latin typeface="Calibri"/>
               </a:rPr>
-              <a:t>Lightweight REST API backend. Serves all data endpoints under /api/</a:t>
+              <a:t>Lightweight REST API backend serving modular endpoints for events, users, and attendees.</a:t>
             </a:r>
           </a:p>
         </p:txBody>
@@ -9352,7 +9368,7 @@
                 </a:solidFill>
                 <a:latin typeface="Calibri"/>
               </a:rPr>
-              <a:t>Cloud-hosted relational database — persistent, scalable, serverless.</a:t>
+              <a:t>Serverless cloud relational database — persistent, scalable, and securely pooled.</a:t>
             </a:r>
           </a:p>
         </p:txBody>
@@ -9508,7 +9524,7 @@
                 </a:solidFill>
                 <a:latin typeface="Calibri"/>
               </a:rPr>
-              <a:t>Google's generative AI for the AI Auto-Fill feature on the admin dashboard.</a:t>
+              <a:t>Google generative AI for 1-click event description and schedule generation for admins.</a:t>
             </a:r>
           </a:p>
         </p:txBody>
@@ -9629,7 +9645,7 @@
                 </a:solidFill>
                 <a:latin typeface="Calibri"/>
               </a:rPr>
-              <a:t>🎨  Vanilla CSS + TW</a:t>
+              <a:t>📨  Brevo Email API</a:t>
             </a:r>
           </a:p>
         </p:txBody>
@@ -9664,7 +9680,7 @@
                 </a:solidFill>
                 <a:latin typeface="Calibri"/>
               </a:rPr>
-              <a:t>Tailwind utility classes for responsive, dark-themed, modern design.</a:t>
+              <a:t>Transactional email delivery for student Welcome passes and event registration tickets.</a:t>
             </a:r>
           </a:p>
         </p:txBody>
@@ -9820,7 +9836,7 @@
                 </a:solidFill>
                 <a:latin typeface="Calibri"/>
               </a:rPr>
-              <a:t>CI/CD pipeline: push to main branch → automatic Vercel deployment.</a:t>
+              <a:t>Automated CI/CD deployment pipeline: git push main triggers instant production builds.</a:t>
             </a:r>
           </a:p>
         </p:txBody>
@@ -9994,7 +10010,7 @@
                 </a:solidFill>
                 <a:latin typeface="Calibri"/>
               </a:rPr>
-              <a:t>How all the pieces fit together</a:t>
+              <a:t>End-to-end dataflow &amp; service integrations</a:t>
             </a:r>
           </a:p>
         </p:txBody>
@@ -10072,8 +10088,8 @@
                 </a:solidFill>
                 <a:latin typeface="Calibri"/>
               </a:rPr>
-              <a:t>👤  User
-(Browser)</a:t>
+              <a:t>👤  User / Admin
+(Mobile &amp; Desktop)</a:t>
             </a:r>
           </a:p>
         </p:txBody>
@@ -10151,8 +10167,7 @@
                 </a:solidFill>
                 <a:latin typeface="Calibri"/>
               </a:rPr>
-              <a:t>⚛  React
-Frontend
+              <a:t>⚛  React Client
 (Vite / Vercel)</a:t>
             </a:r>
           </a:p>
@@ -10231,9 +10246,8 @@
                 </a:solidFill>
                 <a:latin typeface="Calibri"/>
               </a:rPr>
-              <a:t>🐍  Flask
-REST API
-(Python)</a:t>
+              <a:t>🐍  Flask Backend
+(REST API Services)</a:t>
             </a:r>
           </a:p>
         </p:txBody>
@@ -10311,9 +10325,8 @@
                 </a:solidFill>
                 <a:latin typeface="Calibri"/>
               </a:rPr>
-              <a:t>🗄  Neon
-PostgreSQL
-(Cloud DB)</a:t>
+              <a:t>🗄  Neon Cloud
+(PostgreSQL DB)</a:t>
             </a:r>
           </a:p>
         </p:txBody>
@@ -10560,8 +10573,8 @@
         </p:nvSpPr>
         <p:spPr>
           <a:xfrm>
-            <a:off x="6035040" y="4663440"/>
-            <a:ext cx="2377440" cy="1097280"/>
+            <a:off x="4206240" y="4572000"/>
+            <a:ext cx="3108960" cy="1234440"/>
           </a:xfrm>
           <a:prstGeom prst="rect">
             <a:avLst/>
@@ -10603,8 +10616,8 @@
         </p:nvSpPr>
         <p:spPr>
           <a:xfrm>
-            <a:off x="6144768" y="4754880"/>
-            <a:ext cx="2176272" cy="914400"/>
+            <a:off x="4297680" y="4681728"/>
+            <a:ext cx="2926080" cy="822960"/>
           </a:xfrm>
           <a:prstGeom prst="rect">
             <a:avLst/>
@@ -10625,8 +10638,8 @@
                 </a:solidFill>
                 <a:latin typeface="Calibri"/>
               </a:rPr>
-              <a:t>🤖  Gemini AI
-(Text Gen)</a:t>
+              <a:t>🤖  Google Gemini AI
+(AI Event Auto-Fill)</a:t>
             </a:r>
           </a:p>
         </p:txBody>
@@ -10639,8 +10652,8 @@
         </p:nvSpPr>
         <p:spPr>
           <a:xfrm>
-            <a:off x="6400800" y="4206240"/>
-            <a:ext cx="1920240" cy="438912"/>
+            <a:off x="4297680" y="4251960"/>
+            <a:ext cx="2926080" cy="320040"/>
           </a:xfrm>
           <a:prstGeom prst="rect">
             <a:avLst/>
@@ -10661,21 +10674,135 @@
                 </a:solidFill>
                 <a:latin typeface="Calibri"/>
               </a:rPr>
-              <a:t>↕ AI auto-fill</a:t>
-            </a:r>
-          </a:p>
-        </p:txBody>
-      </p:sp>
-      <p:sp>
-        <p:nvSpPr>
-          <p:cNvPr id="23" name="TextBox 22"/>
-          <p:cNvSpPr txBox="1"/>
-          <p:nvPr/>
-        </p:nvSpPr>
-        <p:spPr>
-          <a:xfrm>
-            <a:off x="457200" y="5989320"/>
-            <a:ext cx="10972800" cy="502920"/>
+              <a:t>↕ Event copywriting</a:t>
+            </a:r>
+          </a:p>
+        </p:txBody>
+      </p:sp>
+      <p:sp>
+        <p:nvSpPr>
+          <p:cNvPr id="23" name="Rectangle 22"/>
+          <p:cNvSpPr/>
+          <p:nvPr/>
+        </p:nvSpPr>
+        <p:spPr>
+          <a:xfrm>
+            <a:off x="7680960" y="4572000"/>
+            <a:ext cx="3566160" cy="1234440"/>
+          </a:xfrm>
+          <a:prstGeom prst="rect">
+            <a:avLst/>
+          </a:prstGeom>
+          <a:solidFill>
+            <a:srgbClr val="1A2E26"/>
+          </a:solidFill>
+          <a:ln>
+            <a:noFill/>
+          </a:ln>
+        </p:spPr>
+        <p:style>
+          <a:lnRef idx="1">
+            <a:schemeClr val="accent1"/>
+          </a:lnRef>
+          <a:fillRef idx="3">
+            <a:schemeClr val="accent1"/>
+          </a:fillRef>
+          <a:effectRef idx="2">
+            <a:schemeClr val="accent1"/>
+          </a:effectRef>
+          <a:fontRef idx="minor">
+            <a:schemeClr val="lt1"/>
+          </a:fontRef>
+        </p:style>
+        <p:txBody>
+          <a:bodyPr rtlCol="0" anchor="ctr"/>
+          <a:lstStyle/>
+          <a:p>
+            <a:pPr algn="ctr"/>
+          </a:p>
+        </p:txBody>
+      </p:sp>
+      <p:sp>
+        <p:nvSpPr>
+          <p:cNvPr id="24" name="TextBox 23"/>
+          <p:cNvSpPr txBox="1"/>
+          <p:nvPr/>
+        </p:nvSpPr>
+        <p:spPr>
+          <a:xfrm>
+            <a:off x="7772400" y="4681728"/>
+            <a:ext cx="3383280" cy="822960"/>
+          </a:xfrm>
+          <a:prstGeom prst="rect">
+            <a:avLst/>
+          </a:prstGeom>
+          <a:noFill/>
+        </p:spPr>
+        <p:txBody>
+          <a:bodyPr wrap="square">
+            <a:spAutoFit/>
+          </a:bodyPr>
+          <a:lstStyle/>
+          <a:p>
+            <a:pPr algn="ctr"/>
+            <a:r>
+              <a:rPr sz="1300" b="1" i="0">
+                <a:solidFill>
+                  <a:srgbClr val="CFE870"/>
+                </a:solidFill>
+                <a:latin typeface="Calibri"/>
+              </a:rPr>
+              <a:t>📨  Brevo Email API (v3)
+(Welcome &amp; Event Passes)</a:t>
+            </a:r>
+          </a:p>
+        </p:txBody>
+      </p:sp>
+      <p:sp>
+        <p:nvSpPr>
+          <p:cNvPr id="25" name="TextBox 24"/>
+          <p:cNvSpPr txBox="1"/>
+          <p:nvPr/>
+        </p:nvSpPr>
+        <p:spPr>
+          <a:xfrm>
+            <a:off x="7772400" y="4251960"/>
+            <a:ext cx="3383280" cy="320040"/>
+          </a:xfrm>
+          <a:prstGeom prst="rect">
+            <a:avLst/>
+          </a:prstGeom>
+          <a:noFill/>
+        </p:spPr>
+        <p:txBody>
+          <a:bodyPr wrap="square">
+            <a:spAutoFit/>
+          </a:bodyPr>
+          <a:lstStyle/>
+          <a:p>
+            <a:pPr algn="ctr"/>
+            <a:r>
+              <a:rPr sz="1100" b="0" i="1">
+                <a:solidFill>
+                  <a:srgbClr val="76817B"/>
+                </a:solidFill>
+                <a:latin typeface="Calibri"/>
+              </a:rPr>
+              <a:t>↕ Async email dispatch</a:t>
+            </a:r>
+          </a:p>
+        </p:txBody>
+      </p:sp>
+      <p:sp>
+        <p:nvSpPr>
+          <p:cNvPr id="26" name="TextBox 25"/>
+          <p:cNvSpPr txBox="1"/>
+          <p:nvPr/>
+        </p:nvSpPr>
+        <p:spPr>
+          <a:xfrm>
+            <a:off x="457200" y="6080760"/>
+            <a:ext cx="10972800" cy="411480"/>
           </a:xfrm>
           <a:prstGeom prst="rect">
             <a:avLst/>
@@ -10696,7 +10823,7 @@
                 </a:solidFill>
                 <a:latin typeface="Calibri"/>
               </a:rPr>
-              <a:t>Vite proxy forwards /api/* calls to Flask during development</a:t>
+              <a:t>Fully decoupled architecture with background threading for instant client response times</a:t>
             </a:r>
           </a:p>
         </p:txBody>
@@ -11513,7 +11640,7 @@
                 </a:solidFill>
                 <a:latin typeface="Calibri"/>
               </a:rPr>
-              <a:t>👤  Profile</a:t>
+              <a:t>📨  Email Event Pass</a:t>
             </a:r>
           </a:p>
         </p:txBody>
@@ -11548,7 +11675,7 @@
                 </a:solidFill>
                 <a:latin typeface="Calibri"/>
               </a:rPr>
-              <a:t>Personal profile page showing name, email, registration number, department and class.</a:t>
+              <a:t>Instant confirmation email delivered via Brevo with event timing, venue directions, and reminders.</a:t>
             </a:r>
           </a:p>
         </p:txBody>
@@ -11722,7 +11849,7 @@
                 </a:solidFill>
                 <a:latin typeface="Calibri"/>
               </a:rPr>
-              <a:t>Powerful tools for event coordinators</a:t>
+              <a:t>Comprehensive control &amp; student attendee management</a:t>
             </a:r>
           </a:p>
         </p:txBody>
@@ -11837,13 +11964,13 @@
           <a:p>
             <a:pPr algn="l"/>
             <a:r>
-              <a:rPr sz="1600" b="1" i="0">
+              <a:rPr sz="1550" b="1" i="0">
                 <a:solidFill>
                   <a:srgbClr val="CFE870"/>
                 </a:solidFill>
                 <a:latin typeface="Calibri"/>
               </a:rPr>
-              <a:t>📊  Live Dashboard</a:t>
+              <a:t>👥  Registered Student Rosters</a:t>
             </a:r>
           </a:p>
         </p:txBody>
@@ -11872,13 +11999,13 @@
           <a:p>
             <a:pPr algn="l"/>
             <a:r>
-              <a:rPr sz="1400" b="0" i="0">
+              <a:rPr sz="1350" b="0" i="0">
                 <a:solidFill>
                   <a:srgbClr val="FFFEFA"/>
                 </a:solidFill>
                 <a:latin typeface="Calibri"/>
               </a:rPr>
-              <a:t>At-a-glance stats: total events live, total student registrations, and total registered students.</a:t>
+              <a:t>Admins can view the full list of enrolled students for any event with name, reg number, department, class, and email.</a:t>
             </a:r>
           </a:p>
         </p:txBody>
@@ -11993,13 +12120,13 @@
           <a:p>
             <a:pPr algn="l"/>
             <a:r>
-              <a:rPr sz="1600" b="1" i="0">
+              <a:rPr sz="1550" b="1" i="0">
                 <a:solidFill>
                   <a:srgbClr val="CFE870"/>
                 </a:solidFill>
                 <a:latin typeface="Calibri"/>
               </a:rPr>
-              <a:t>✨  AI Auto-Fill</a:t>
+              <a:t>📥  CSV Export &amp; Print</a:t>
             </a:r>
           </a:p>
         </p:txBody>
@@ -12028,13 +12155,13 @@
           <a:p>
             <a:pPr algn="l"/>
             <a:r>
-              <a:rPr sz="1400" b="0" i="0">
+              <a:rPr sz="1350" b="0" i="0">
                 <a:solidFill>
                   <a:srgbClr val="FFFEFA"/>
                 </a:solidFill>
                 <a:latin typeface="Calibri"/>
               </a:rPr>
-              <a:t>Describe an event in plain English (e.g. 'hackathon on friday with prizes') and Gemini AI generates a full event listing.</a:t>
+              <a:t>Export attendee lists to CSV for offline attendance tracking or print the roster directly for campus gate checks.</a:t>
             </a:r>
           </a:p>
         </p:txBody>
@@ -12149,13 +12276,13 @@
           <a:p>
             <a:pPr algn="l"/>
             <a:r>
-              <a:rPr sz="1600" b="1" i="0">
+              <a:rPr sz="1550" b="1" i="0">
                 <a:solidFill>
                   <a:srgbClr val="CFE870"/>
                 </a:solidFill>
                 <a:latin typeface="Calibri"/>
               </a:rPr>
-              <a:t>📝  Publish Events</a:t>
+              <a:t>✨  AI Auto-Fill</a:t>
             </a:r>
           </a:p>
         </p:txBody>
@@ -12184,13 +12311,13 @@
           <a:p>
             <a:pPr algn="l"/>
             <a:r>
-              <a:rPr sz="1400" b="0" i="0">
+              <a:rPr sz="1350" b="0" i="0">
                 <a:solidFill>
                   <a:srgbClr val="FFFEFA"/>
                 </a:solidFill>
                 <a:latin typeface="Calibri"/>
               </a:rPr>
-              <a:t>Fill in the event form (title, date, time, venue, deadline, category, description) and publish instantly to all students.</a:t>
+              <a:t>Type a rough idea (e.g. 'hackathon on friday with prizes') and Gemini AI generates the full structured event listing.</a:t>
             </a:r>
           </a:p>
         </p:txBody>
@@ -12305,13 +12432,13 @@
           <a:p>
             <a:pPr algn="l"/>
             <a:r>
-              <a:rPr sz="1600" b="1" i="0">
+              <a:rPr sz="1550" b="1" i="0">
                 <a:solidFill>
                   <a:srgbClr val="CFE870"/>
                 </a:solidFill>
                 <a:latin typeface="Calibri"/>
               </a:rPr>
-              <a:t>🗑  Delete Events</a:t>
+              <a:t>📊  Live Analytics &amp; Deletion</a:t>
             </a:r>
           </a:p>
         </p:txBody>
@@ -12340,13 +12467,13 @@
           <a:p>
             <a:pPr algn="l"/>
             <a:r>
-              <a:rPr sz="1400" b="0" i="0">
+              <a:rPr sz="1350" b="0" i="0">
                 <a:solidFill>
                   <a:srgbClr val="FFFEFA"/>
                 </a:solidFill>
                 <a:latin typeface="Calibri"/>
               </a:rPr>
-              <a:t>Remove any event with a single click. Associated student registrations are automatically cleaned up from the database.</a:t>
+              <a:t>Monitor live counts of active events, registrations, and registered students with clean event lifecycle management.</a:t>
             </a:r>
           </a:p>
         </p:txBody>
@@ -12485,7 +12612,7 @@
                 </a:solidFill>
                 <a:latin typeface="Calibri"/>
               </a:rPr>
-              <a:t>AI Integration</a:t>
+              <a:t>AI &amp; Transactional Email Services</a:t>
             </a:r>
           </a:p>
         </p:txBody>
@@ -12520,7 +12647,7 @@
                 </a:solidFill>
                 <a:latin typeface="Calibri"/>
               </a:rPr>
-              <a:t>Powered by Google Gemini AI</a:t>
+              <a:t>Automated intelligence with Google Gemini &amp; Brevo</a:t>
             </a:r>
           </a:p>
         </p:txBody>
@@ -12592,13 +12719,13 @@
           <a:p>
             <a:pPr algn="l"/>
             <a:r>
-              <a:rPr sz="1600" b="0" i="0">
+              <a:rPr sz="1550" b="0" i="0">
                 <a:solidFill>
                   <a:srgbClr val="FFFEFA"/>
                 </a:solidFill>
                 <a:latin typeface="Calibri"/>
               </a:rPr>
-              <a:t>The admin dashboard includes an AI Auto-Fill panel backed by the google-genai SDK. Type a rough idea and Gemini generates a complete, polished event listing in under 3 seconds.</a:t>
+              <a:t>Campus Circle integrates AI-assisted event creation and automated email dispatching. Admins draft events in seconds while students receive instant branded registration passes in their inbox.</a:t>
             </a:r>
           </a:p>
         </p:txBody>
@@ -12754,7 +12881,7 @@
                 </a:solidFill>
                 <a:latin typeface="Calibri"/>
               </a:rPr>
-              <a:t>Admin types a prompt</a:t>
+              <a:t>AI Auto-Fill</a:t>
             </a:r>
           </a:p>
         </p:txBody>
@@ -12789,7 +12916,7 @@
                 </a:solidFill>
                 <a:latin typeface="Calibri"/>
               </a:rPr>
-              <a:t>e.g. 'coding contest for freshers with prizes and snacks on saturday'</a:t>
+              <a:t>Admin types brief idea → Gemini AI generates polished title, category, description, and timing.</a:t>
             </a:r>
           </a:p>
         </p:txBody>
@@ -12945,7 +13072,7 @@
                 </a:solidFill>
                 <a:latin typeface="Calibri"/>
               </a:rPr>
-              <a:t>Request → Flask API</a:t>
+              <a:t>Instant Publishing</a:t>
             </a:r>
           </a:p>
         </p:txBody>
@@ -12980,7 +13107,7 @@
                 </a:solidFill>
                 <a:latin typeface="Calibri"/>
               </a:rPr>
-              <a:t>POST /api/ai/generate-event sends prompt to Gemini model</a:t>
+              <a:t>Event is validated and stored in Neon PostgreSQL cloud DB, immediately live on Discover.</a:t>
             </a:r>
           </a:p>
         </p:txBody>
@@ -13136,7 +13263,7 @@
                 </a:solidFill>
                 <a:latin typeface="Calibri"/>
               </a:rPr>
-              <a:t>Gemini generates JSON</a:t>
+              <a:t>Welcome Email</a:t>
             </a:r>
           </a:p>
         </p:txBody>
@@ -13171,7 +13298,7 @@
                 </a:solidFill>
                 <a:latin typeface="Calibri"/>
               </a:rPr>
-              <a:t>Returns: title, category, description, time, venue as structured JSON</a:t>
+              <a:t>New student registers → Brevo API sends a branded welcome email with profile credentials.</a:t>
             </a:r>
           </a:p>
         </p:txBody>
@@ -13327,7 +13454,7 @@
                 </a:solidFill>
                 <a:latin typeface="Calibri"/>
               </a:rPr>
-              <a:t>Form auto-fills</a:t>
+              <a:t>Event Ticket Pass</a:t>
             </a:r>
           </a:p>
         </p:txBody>
@@ -13362,7 +13489,7 @@
                 </a:solidFill>
                 <a:latin typeface="Calibri"/>
               </a:rPr>
-              <a:t>All event fields populate instantly. Admin reviews and clicks Publish.</a:t>
+              <a:t>Student clicks Register → Brevo dispatches a ticket pass with schedule, venue, and reminders.</a:t>
             </a:r>
           </a:p>
         </p:txBody>
@@ -13397,7 +13524,7 @@
                 </a:solidFill>
                 <a:latin typeface="Calibri"/>
               </a:rPr>
-              <a:t>Fallback models: gemini-2.5-flash → gemini-flash-latest  |  Rate-limit resilience built in</a:t>
+              <a:t>Multi-model AI fallback: gemini-3.5-flash → gemini-flash-latest  |  Async background email threading</a:t>
             </a:r>
           </a:p>
         </p:txBody>
@@ -14160,7 +14287,7 @@
                 </a:solidFill>
                 <a:latin typeface="Calibri"/>
               </a:rPr>
-              <a:t>• ✅  Student name pulled from account</a:t>
+              <a:t>• ✅  Student name pulled from verified account</a:t>
             </a:r>
           </a:p>
           <a:p>
@@ -15095,7 +15222,7 @@
                 </a:solidFill>
                 <a:latin typeface="Courier New"/>
               </a:rPr>
-              <a:t>date          DATE</a:t>
+              <a:t>date          TEXT</a:t>
             </a:r>
           </a:p>
         </p:txBody>
@@ -15200,7 +15327,7 @@
                 </a:solidFill>
                 <a:latin typeface="Courier New"/>
               </a:rPr>
-              <a:t>deadline      DATE</a:t>
+              <a:t>deadline      TEXT</a:t>
             </a:r>
           </a:p>
         </p:txBody>
@@ -15601,7 +15728,7 @@
                 </a:solidFill>
                 <a:latin typeface="Courier New"/>
               </a:rPr>
-              <a:t>registered_at TIMESTAMP</a:t>
+              <a:t>created_at    TIMESTAMP</a:t>
             </a:r>
           </a:p>
         </p:txBody>
@@ -15672,6 +15799,41 @@
                 <a:latin typeface="Courier New"/>
               </a:rPr>
               <a:t>UNIQUE(user_id, event_id)</a:t>
+            </a:r>
+          </a:p>
+        </p:txBody>
+      </p:sp>
+      <p:sp>
+        <p:nvSpPr>
+          <p:cNvPr id="41" name="TextBox 40"/>
+          <p:cNvSpPr txBox="1"/>
+          <p:nvPr/>
+        </p:nvSpPr>
+        <p:spPr>
+          <a:xfrm>
+            <a:off x="8348471" y="5056632"/>
+            <a:ext cx="3493008" cy="365760"/>
+          </a:xfrm>
+          <a:prstGeom prst="rect">
+            <a:avLst/>
+          </a:prstGeom>
+          <a:noFill/>
+        </p:spPr>
+        <p:txBody>
+          <a:bodyPr wrap="square">
+            <a:spAutoFit/>
+          </a:bodyPr>
+          <a:lstStyle/>
+          <a:p>
+            <a:pPr algn="l"/>
+            <a:r>
+              <a:rPr sz="1150" b="0" i="0">
+                <a:solidFill>
+                  <a:srgbClr val="FFFEFA"/>
+                </a:solidFill>
+                <a:latin typeface="Courier New"/>
+              </a:rPr>
+              <a:t>JOIN user_id → Attendee List</a:t>
             </a:r>
           </a:p>
         </p:txBody>

</xml_diff>

<commit_message>
feat: New mobile-responsive certificate design matching reference template with gold seal and QR code
</commit_message>
<xml_diff>
--- a/CampusCircle_Presentation.pptx
+++ b/CampusCircle_Presentation.pptx
@@ -13698,7 +13698,7 @@
                 </a:solidFill>
                 <a:latin typeface="Calibri"/>
               </a:rPr>
-              <a:t>Printable participation certificates for every student</a:t>
+              <a:t>Printable participation credentials &amp; digital verification</a:t>
             </a:r>
           </a:p>
         </p:txBody>
@@ -13718,10 +13718,12 @@
             <a:avLst/>
           </a:prstGeom>
           <a:solidFill>
-            <a:srgbClr val="FFFEFA"/>
+            <a:srgbClr val="FFFFFF"/>
           </a:solidFill>
-          <a:ln>
-            <a:noFill/>
+          <a:ln w="12700">
+            <a:solidFill>
+              <a:srgbClr val="CFD6D1"/>
+            </a:solidFill>
           </a:ln>
         </p:spPr>
         <p:style>
@@ -13755,225 +13757,7 @@
         <p:spPr>
           <a:xfrm>
             <a:off x="365760" y="1417320"/>
-            <a:ext cx="7498079" cy="4846320"/>
-          </a:xfrm>
-          <a:prstGeom prst="rect">
-            <a:avLst/>
-          </a:prstGeom>
-          <a:noFill/>
-          <a:ln w="127000">
-            <a:solidFill>
-              <a:srgbClr val="243B31"/>
-            </a:solidFill>
-          </a:ln>
-        </p:spPr>
-        <p:style>
-          <a:lnRef idx="1">
-            <a:schemeClr val="accent1"/>
-          </a:lnRef>
-          <a:fillRef idx="3">
-            <a:schemeClr val="accent1"/>
-          </a:fillRef>
-          <a:effectRef idx="2">
-            <a:schemeClr val="accent1"/>
-          </a:effectRef>
-          <a:fontRef idx="minor">
-            <a:schemeClr val="lt1"/>
-          </a:fontRef>
-        </p:style>
-        <p:txBody>
-          <a:bodyPr rtlCol="0" anchor="ctr"/>
-          <a:lstStyle/>
-          <a:p>
-            <a:pPr algn="ctr"/>
-          </a:p>
-        </p:txBody>
-      </p:sp>
-      <p:sp>
-        <p:nvSpPr>
-          <p:cNvPr id="8" name="TextBox 7"/>
-          <p:cNvSpPr txBox="1"/>
-          <p:nvPr/>
-        </p:nvSpPr>
-        <p:spPr>
-          <a:xfrm>
-            <a:off x="502920" y="1645920"/>
-            <a:ext cx="7315200" cy="868680"/>
-          </a:xfrm>
-          <a:prstGeom prst="rect">
-            <a:avLst/>
-          </a:prstGeom>
-          <a:noFill/>
-        </p:spPr>
-        <p:txBody>
-          <a:bodyPr wrap="square">
-            <a:spAutoFit/>
-          </a:bodyPr>
-          <a:lstStyle/>
-          <a:p>
-            <a:pPr algn="ctr"/>
-            <a:r>
-              <a:rPr sz="2800" b="1" i="0">
-                <a:solidFill>
-                  <a:srgbClr val="243B31"/>
-                </a:solidFill>
-                <a:latin typeface="Georgia"/>
-              </a:rPr>
-              <a:t>Certificate of Participation</a:t>
-            </a:r>
-          </a:p>
-        </p:txBody>
-      </p:sp>
-      <p:sp>
-        <p:nvSpPr>
-          <p:cNvPr id="9" name="TextBox 8"/>
-          <p:cNvSpPr txBox="1"/>
-          <p:nvPr/>
-        </p:nvSpPr>
-        <p:spPr>
-          <a:xfrm>
-            <a:off x="502920" y="2514600"/>
-            <a:ext cx="7315200" cy="365760"/>
-          </a:xfrm>
-          <a:prstGeom prst="rect">
-            <a:avLst/>
-          </a:prstGeom>
-          <a:noFill/>
-        </p:spPr>
-        <p:txBody>
-          <a:bodyPr wrap="square">
-            <a:spAutoFit/>
-          </a:bodyPr>
-          <a:lstStyle/>
-          <a:p>
-            <a:pPr algn="ctr"/>
-            <a:r>
-              <a:rPr sz="1300" b="0" i="0">
-                <a:solidFill>
-                  <a:srgbClr val="76817B"/>
-                </a:solidFill>
-                <a:latin typeface="Calibri"/>
-              </a:rPr>
-              <a:t>This is to certify that</a:t>
-            </a:r>
-          </a:p>
-        </p:txBody>
-      </p:sp>
-      <p:sp>
-        <p:nvSpPr>
-          <p:cNvPr id="10" name="TextBox 9"/>
-          <p:cNvSpPr txBox="1"/>
-          <p:nvPr/>
-        </p:nvSpPr>
-        <p:spPr>
-          <a:xfrm>
-            <a:off x="502920" y="2834640"/>
-            <a:ext cx="7315200" cy="594360"/>
-          </a:xfrm>
-          <a:prstGeom prst="rect">
-            <a:avLst/>
-          </a:prstGeom>
-          <a:noFill/>
-        </p:spPr>
-        <p:txBody>
-          <a:bodyPr wrap="square">
-            <a:spAutoFit/>
-          </a:bodyPr>
-          <a:lstStyle/>
-          <a:p>
-            <a:pPr algn="ctr"/>
-            <a:r>
-              <a:rPr sz="2600" b="1" i="0">
-                <a:solidFill>
-                  <a:srgbClr val="243B31"/>
-                </a:solidFill>
-                <a:latin typeface="Georgia"/>
-              </a:rPr>
-              <a:t>Abhilash R</a:t>
-            </a:r>
-          </a:p>
-        </p:txBody>
-      </p:sp>
-      <p:sp>
-        <p:nvSpPr>
-          <p:cNvPr id="11" name="TextBox 10"/>
-          <p:cNvSpPr txBox="1"/>
-          <p:nvPr/>
-        </p:nvSpPr>
-        <p:spPr>
-          <a:xfrm>
-            <a:off x="502920" y="3401568"/>
-            <a:ext cx="7315200" cy="365760"/>
-          </a:xfrm>
-          <a:prstGeom prst="rect">
-            <a:avLst/>
-          </a:prstGeom>
-          <a:noFill/>
-        </p:spPr>
-        <p:txBody>
-          <a:bodyPr wrap="square">
-            <a:spAutoFit/>
-          </a:bodyPr>
-          <a:lstStyle/>
-          <a:p>
-            <a:pPr algn="ctr"/>
-            <a:r>
-              <a:rPr sz="1300" b="0" i="0">
-                <a:solidFill>
-                  <a:srgbClr val="76817B"/>
-                </a:solidFill>
-                <a:latin typeface="Calibri"/>
-              </a:rPr>
-              <a:t>has successfully participated in</a:t>
-            </a:r>
-          </a:p>
-        </p:txBody>
-      </p:sp>
-      <p:sp>
-        <p:nvSpPr>
-          <p:cNvPr id="12" name="TextBox 11"/>
-          <p:cNvSpPr txBox="1"/>
-          <p:nvPr/>
-        </p:nvSpPr>
-        <p:spPr>
-          <a:xfrm>
-            <a:off x="502920" y="3730752"/>
-            <a:ext cx="7315200" cy="502920"/>
-          </a:xfrm>
-          <a:prstGeom prst="rect">
-            <a:avLst/>
-          </a:prstGeom>
-          <a:noFill/>
-        </p:spPr>
-        <p:txBody>
-          <a:bodyPr wrap="square">
-            <a:spAutoFit/>
-          </a:bodyPr>
-          <a:lstStyle/>
-          <a:p>
-            <a:pPr algn="ctr"/>
-            <a:r>
-              <a:rPr sz="2000" b="1" i="0">
-                <a:solidFill>
-                  <a:srgbClr val="243B31"/>
-                </a:solidFill>
-                <a:latin typeface="Georgia"/>
-              </a:rPr>
-              <a:t>CodeCraft Hackathon</a:t>
-            </a:r>
-          </a:p>
-        </p:txBody>
-      </p:sp>
-      <p:sp>
-        <p:nvSpPr>
-          <p:cNvPr id="13" name="Rectangle 12"/>
-          <p:cNvSpPr/>
-          <p:nvPr/>
-        </p:nvSpPr>
-        <p:spPr>
-          <a:xfrm>
-            <a:off x="822960" y="5120640"/>
-            <a:ext cx="2286000" cy="36576"/>
+            <a:ext cx="256032" cy="4846320"/>
           </a:xfrm>
           <a:prstGeom prst="rect">
             <a:avLst/>
@@ -14009,14 +13793,206 @@
       </p:sp>
       <p:sp>
         <p:nvSpPr>
-          <p:cNvPr id="14" name="Rectangle 13"/>
+          <p:cNvPr id="8" name="Rectangle 7"/>
           <p:cNvSpPr/>
           <p:nvPr/>
         </p:nvSpPr>
         <p:spPr>
           <a:xfrm>
-            <a:off x="5029200" y="5120640"/>
-            <a:ext cx="2286000" cy="36576"/>
+            <a:off x="777240" y="1645920"/>
+            <a:ext cx="73152" cy="658368"/>
+          </a:xfrm>
+          <a:prstGeom prst="rect">
+            <a:avLst/>
+          </a:prstGeom>
+          <a:solidFill>
+            <a:srgbClr val="9FB88D"/>
+          </a:solidFill>
+          <a:ln>
+            <a:noFill/>
+          </a:ln>
+        </p:spPr>
+        <p:style>
+          <a:lnRef idx="1">
+            <a:schemeClr val="accent1"/>
+          </a:lnRef>
+          <a:fillRef idx="3">
+            <a:schemeClr val="accent1"/>
+          </a:fillRef>
+          <a:effectRef idx="2">
+            <a:schemeClr val="accent1"/>
+          </a:effectRef>
+          <a:fontRef idx="minor">
+            <a:schemeClr val="lt1"/>
+          </a:fontRef>
+        </p:style>
+        <p:txBody>
+          <a:bodyPr rtlCol="0" anchor="ctr"/>
+          <a:lstStyle/>
+          <a:p>
+            <a:pPr algn="ctr"/>
+          </a:p>
+        </p:txBody>
+      </p:sp>
+      <p:sp>
+        <p:nvSpPr>
+          <p:cNvPr id="9" name="TextBox 8"/>
+          <p:cNvSpPr txBox="1"/>
+          <p:nvPr/>
+        </p:nvSpPr>
+        <p:spPr>
+          <a:xfrm>
+            <a:off x="960120" y="1627632"/>
+            <a:ext cx="4114800" cy="256032"/>
+          </a:xfrm>
+          <a:prstGeom prst="rect">
+            <a:avLst/>
+          </a:prstGeom>
+          <a:noFill/>
+        </p:spPr>
+        <p:txBody>
+          <a:bodyPr wrap="square">
+            <a:spAutoFit/>
+          </a:bodyPr>
+          <a:lstStyle/>
+          <a:p>
+            <a:pPr algn="l"/>
+            <a:r>
+              <a:rPr sz="1000" b="1" i="0">
+                <a:solidFill>
+                  <a:srgbClr val="243B31"/>
+                </a:solidFill>
+                <a:latin typeface="Calibri"/>
+              </a:rPr>
+              <a:t>AUTHORIZED</a:t>
+            </a:r>
+          </a:p>
+        </p:txBody>
+      </p:sp>
+      <p:sp>
+        <p:nvSpPr>
+          <p:cNvPr id="10" name="TextBox 9"/>
+          <p:cNvSpPr txBox="1"/>
+          <p:nvPr/>
+        </p:nvSpPr>
+        <p:spPr>
+          <a:xfrm>
+            <a:off x="960120" y="1874519"/>
+            <a:ext cx="4114800" cy="411480"/>
+          </a:xfrm>
+          <a:prstGeom prst="rect">
+            <a:avLst/>
+          </a:prstGeom>
+          <a:noFill/>
+        </p:spPr>
+        <p:txBody>
+          <a:bodyPr wrap="square">
+            <a:spAutoFit/>
+          </a:bodyPr>
+          <a:lstStyle/>
+          <a:p>
+            <a:pPr algn="l"/>
+            <a:r>
+              <a:rPr sz="1600" b="1" i="0">
+                <a:solidFill>
+                  <a:srgbClr val="243B31"/>
+                </a:solidFill>
+                <a:latin typeface="Calibri"/>
+              </a:rPr>
+              <a:t>DISTRIBUTOR CERTIFICATE</a:t>
+            </a:r>
+          </a:p>
+        </p:txBody>
+      </p:sp>
+      <p:sp>
+        <p:nvSpPr>
+          <p:cNvPr id="11" name="Rectangle 10"/>
+          <p:cNvSpPr/>
+          <p:nvPr/>
+        </p:nvSpPr>
+        <p:spPr>
+          <a:xfrm>
+            <a:off x="6126480" y="1572768"/>
+            <a:ext cx="731520" cy="731520"/>
+          </a:xfrm>
+          <a:prstGeom prst="rect">
+            <a:avLst/>
+          </a:prstGeom>
+          <a:solidFill>
+            <a:srgbClr val="DFB746"/>
+          </a:solidFill>
+          <a:ln>
+            <a:noFill/>
+          </a:ln>
+        </p:spPr>
+        <p:style>
+          <a:lnRef idx="1">
+            <a:schemeClr val="accent1"/>
+          </a:lnRef>
+          <a:fillRef idx="3">
+            <a:schemeClr val="accent1"/>
+          </a:fillRef>
+          <a:effectRef idx="2">
+            <a:schemeClr val="accent1"/>
+          </a:effectRef>
+          <a:fontRef idx="minor">
+            <a:schemeClr val="lt1"/>
+          </a:fontRef>
+        </p:style>
+        <p:txBody>
+          <a:bodyPr rtlCol="0" anchor="ctr"/>
+          <a:lstStyle/>
+          <a:p>
+            <a:pPr algn="ctr"/>
+          </a:p>
+        </p:txBody>
+      </p:sp>
+      <p:sp>
+        <p:nvSpPr>
+          <p:cNvPr id="12" name="TextBox 11"/>
+          <p:cNvSpPr txBox="1"/>
+          <p:nvPr/>
+        </p:nvSpPr>
+        <p:spPr>
+          <a:xfrm>
+            <a:off x="6126480" y="1609344"/>
+            <a:ext cx="731520" cy="640080"/>
+          </a:xfrm>
+          <a:prstGeom prst="rect">
+            <a:avLst/>
+          </a:prstGeom>
+          <a:noFill/>
+        </p:spPr>
+        <p:txBody>
+          <a:bodyPr wrap="square">
+            <a:spAutoFit/>
+          </a:bodyPr>
+          <a:lstStyle/>
+          <a:p>
+            <a:pPr algn="ctr"/>
+            <a:r>
+              <a:rPr sz="1000" b="1" i="0">
+                <a:solidFill>
+                  <a:srgbClr val="4A3305"/>
+                </a:solidFill>
+                <a:latin typeface="Calibri"/>
+              </a:rPr>
+              <a:t>★
+2026</a:t>
+            </a:r>
+          </a:p>
+        </p:txBody>
+      </p:sp>
+      <p:sp>
+        <p:nvSpPr>
+          <p:cNvPr id="13" name="Rectangle 12"/>
+          <p:cNvSpPr/>
+          <p:nvPr/>
+        </p:nvSpPr>
+        <p:spPr>
+          <a:xfrm>
+            <a:off x="6949440" y="1600200"/>
+            <a:ext cx="658368" cy="658368"/>
           </a:xfrm>
           <a:prstGeom prst="rect">
             <a:avLst/>
@@ -14052,70 +14028,105 @@
       </p:sp>
       <p:sp>
         <p:nvSpPr>
+          <p:cNvPr id="14" name="TextBox 13"/>
+          <p:cNvSpPr txBox="1"/>
+          <p:nvPr/>
+        </p:nvSpPr>
+        <p:spPr>
+          <a:xfrm>
+            <a:off x="6949440" y="1737360"/>
+            <a:ext cx="658368" cy="365760"/>
+          </a:xfrm>
+          <a:prstGeom prst="rect">
+            <a:avLst/>
+          </a:prstGeom>
+          <a:noFill/>
+        </p:spPr>
+        <p:txBody>
+          <a:bodyPr wrap="square">
+            <a:spAutoFit/>
+          </a:bodyPr>
+          <a:lstStyle/>
+          <a:p>
+            <a:pPr algn="ctr"/>
+            <a:r>
+              <a:rPr sz="1100" b="1" i="0">
+                <a:solidFill>
+                  <a:srgbClr val="FFFFFF"/>
+                </a:solidFill>
+                <a:latin typeface="Calibri"/>
+              </a:rPr>
+              <a:t>QR</a:t>
+            </a:r>
+          </a:p>
+        </p:txBody>
+      </p:sp>
+      <p:sp>
+        <p:nvSpPr>
           <p:cNvPr id="15" name="TextBox 14"/>
           <p:cNvSpPr txBox="1"/>
           <p:nvPr/>
         </p:nvSpPr>
         <p:spPr>
           <a:xfrm>
-            <a:off x="822960" y="4773168"/>
-            <a:ext cx="2286000" cy="365760"/>
-          </a:xfrm>
-          <a:prstGeom prst="rect">
-            <a:avLst/>
-          </a:prstGeom>
-          <a:noFill/>
-        </p:spPr>
-        <p:txBody>
-          <a:bodyPr wrap="square">
-            <a:spAutoFit/>
-          </a:bodyPr>
-          <a:lstStyle/>
-          <a:p>
-            <a:pPr algn="ctr"/>
-            <a:r>
-              <a:rPr sz="1300" b="0" i="1">
+            <a:off x="868680" y="2468880"/>
+            <a:ext cx="5943600" cy="274320"/>
+          </a:xfrm>
+          <a:prstGeom prst="rect">
+            <a:avLst/>
+          </a:prstGeom>
+          <a:noFill/>
+        </p:spPr>
+        <p:txBody>
+          <a:bodyPr wrap="square">
+            <a:spAutoFit/>
+          </a:bodyPr>
+          <a:lstStyle/>
+          <a:p>
+            <a:pPr algn="l"/>
+            <a:r>
+              <a:rPr sz="1100" b="0" i="0">
+                <a:solidFill>
+                  <a:srgbClr val="76817B"/>
+                </a:solidFill>
+                <a:latin typeface="Calibri"/>
+              </a:rPr>
+              <a:t>This certifies that</a:t>
+            </a:r>
+          </a:p>
+        </p:txBody>
+      </p:sp>
+      <p:sp>
+        <p:nvSpPr>
+          <p:cNvPr id="16" name="TextBox 15"/>
+          <p:cNvSpPr txBox="1"/>
+          <p:nvPr/>
+        </p:nvSpPr>
+        <p:spPr>
+          <a:xfrm>
+            <a:off x="868680" y="2743200"/>
+            <a:ext cx="5943600" cy="502920"/>
+          </a:xfrm>
+          <a:prstGeom prst="rect">
+            <a:avLst/>
+          </a:prstGeom>
+          <a:noFill/>
+        </p:spPr>
+        <p:txBody>
+          <a:bodyPr wrap="square">
+            <a:spAutoFit/>
+          </a:bodyPr>
+          <a:lstStyle/>
+          <a:p>
+            <a:pPr algn="l"/>
+            <a:r>
+              <a:rPr sz="2400" b="1" i="0">
                 <a:solidFill>
                   <a:srgbClr val="243B31"/>
                 </a:solidFill>
                 <a:latin typeface="Calibri"/>
               </a:rPr>
-              <a:t>2026-10-11</a:t>
-            </a:r>
-          </a:p>
-        </p:txBody>
-      </p:sp>
-      <p:sp>
-        <p:nvSpPr>
-          <p:cNvPr id="16" name="TextBox 15"/>
-          <p:cNvSpPr txBox="1"/>
-          <p:nvPr/>
-        </p:nvSpPr>
-        <p:spPr>
-          <a:xfrm>
-            <a:off x="5029200" y="5166360"/>
-            <a:ext cx="2286000" cy="365760"/>
-          </a:xfrm>
-          <a:prstGeom prst="rect">
-            <a:avLst/>
-          </a:prstGeom>
-          <a:noFill/>
-        </p:spPr>
-        <p:txBody>
-          <a:bodyPr wrap="square">
-            <a:spAutoFit/>
-          </a:bodyPr>
-          <a:lstStyle/>
-          <a:p>
-            <a:pPr algn="ctr"/>
-            <a:r>
-              <a:rPr sz="900" b="0" i="0">
-                <a:solidFill>
-                  <a:srgbClr val="76817B"/>
-                </a:solidFill>
-                <a:latin typeface="Calibri"/>
-              </a:rPr>
-              <a:t>Authorized Signature</a:t>
+              <a:t>[Abhilash R]</a:t>
             </a:r>
           </a:p>
         </p:txBody>
@@ -14128,17 +14139,19 @@
         </p:nvSpPr>
         <p:spPr>
           <a:xfrm>
-            <a:off x="3611880" y="4754880"/>
-            <a:ext cx="1005840" cy="1005840"/>
+            <a:off x="868680" y="3337560"/>
+            <a:ext cx="6583680" cy="1463040"/>
           </a:xfrm>
           <a:prstGeom prst="rect">
             <a:avLst/>
           </a:prstGeom>
           <a:solidFill>
-            <a:srgbClr val="CFE870"/>
+            <a:srgbClr val="FBFDFB"/>
           </a:solidFill>
-          <a:ln>
-            <a:noFill/>
+          <a:ln w="12700">
+            <a:solidFill>
+              <a:srgbClr val="3B82F6"/>
+            </a:solidFill>
           </a:ln>
         </p:spPr>
         <p:style>
@@ -14171,36 +14184,237 @@
         </p:nvSpPr>
         <p:spPr>
           <a:xfrm>
-            <a:off x="3611880" y="4846320"/>
-            <a:ext cx="1005840" cy="777240"/>
-          </a:xfrm>
-          <a:prstGeom prst="rect">
-            <a:avLst/>
-          </a:prstGeom>
-          <a:noFill/>
-        </p:spPr>
-        <p:txBody>
-          <a:bodyPr wrap="square">
-            <a:spAutoFit/>
-          </a:bodyPr>
-          <a:lstStyle/>
-          <a:p>
-            <a:pPr algn="ctr"/>
-            <a:r>
-              <a:rPr sz="3200" b="1" i="1">
+            <a:off x="1005840" y="3429000"/>
+            <a:ext cx="6309360" cy="1280160"/>
+          </a:xfrm>
+          <a:prstGeom prst="rect">
+            <a:avLst/>
+          </a:prstGeom>
+          <a:noFill/>
+        </p:spPr>
+        <p:txBody>
+          <a:bodyPr wrap="square">
+            <a:spAutoFit/>
+          </a:bodyPr>
+          <a:lstStyle/>
+          <a:p>
+            <a:pPr algn="l"/>
+            <a:r>
+              <a:rPr sz="950" b="0" i="0">
+                <a:solidFill>
+                  <a:srgbClr val="2D3D34"/>
+                </a:solidFill>
+                <a:latin typeface="Calibri"/>
+              </a:rPr>
+              <a:t>is an Authorized Participant for [CodeCraft Hackathon] under the [Campus Circle] product line.
+This authorization applies exclusively to the technical sprint and workshops held on 2026-10-11 at C Block Auditorium, Er. Perumal Manimekalai College of Engineering.</a:t>
+            </a:r>
+          </a:p>
+        </p:txBody>
+      </p:sp>
+      <p:sp>
+        <p:nvSpPr>
+          <p:cNvPr id="19" name="Rectangle 18"/>
+          <p:cNvSpPr/>
+          <p:nvPr/>
+        </p:nvSpPr>
+        <p:spPr>
+          <a:xfrm>
+            <a:off x="5669280" y="5257800"/>
+            <a:ext cx="1737360" cy="18288"/>
+          </a:xfrm>
+          <a:prstGeom prst="rect">
+            <a:avLst/>
+          </a:prstGeom>
+          <a:solidFill>
+            <a:srgbClr val="243B31"/>
+          </a:solidFill>
+          <a:ln>
+            <a:noFill/>
+          </a:ln>
+        </p:spPr>
+        <p:style>
+          <a:lnRef idx="1">
+            <a:schemeClr val="accent1"/>
+          </a:lnRef>
+          <a:fillRef idx="3">
+            <a:schemeClr val="accent1"/>
+          </a:fillRef>
+          <a:effectRef idx="2">
+            <a:schemeClr val="accent1"/>
+          </a:effectRef>
+          <a:fontRef idx="minor">
+            <a:schemeClr val="lt1"/>
+          </a:fontRef>
+        </p:style>
+        <p:txBody>
+          <a:bodyPr rtlCol="0" anchor="ctr"/>
+          <a:lstStyle/>
+          <a:p>
+            <a:pPr algn="ctr"/>
+          </a:p>
+        </p:txBody>
+      </p:sp>
+      <p:sp>
+        <p:nvSpPr>
+          <p:cNvPr id="20" name="TextBox 19"/>
+          <p:cNvSpPr txBox="1"/>
+          <p:nvPr/>
+        </p:nvSpPr>
+        <p:spPr>
+          <a:xfrm>
+            <a:off x="5669280" y="5303520"/>
+            <a:ext cx="1737360" cy="365760"/>
+          </a:xfrm>
+          <a:prstGeom prst="rect">
+            <a:avLst/>
+          </a:prstGeom>
+          <a:noFill/>
+        </p:spPr>
+        <p:txBody>
+          <a:bodyPr wrap="square">
+            <a:spAutoFit/>
+          </a:bodyPr>
+          <a:lstStyle/>
+          <a:p>
+            <a:pPr algn="ctr"/>
+            <a:r>
+              <a:rPr sz="750" b="1" i="0">
                 <a:solidFill>
                   <a:srgbClr val="243B31"/>
                 </a:solidFill>
-                <a:latin typeface="Georgia"/>
-              </a:rPr>
-              <a:t>C.</a:t>
-            </a:r>
-          </a:p>
-        </p:txBody>
-      </p:sp>
-      <p:sp>
-        <p:nvSpPr>
-          <p:cNvPr id="19" name="Rectangle 18"/>
+                <a:latin typeface="Calibri"/>
+              </a:rPr>
+              <a:t>[Abhilash R]
+[AUTHORIZED SIGNATORY]</a:t>
+            </a:r>
+          </a:p>
+        </p:txBody>
+      </p:sp>
+      <p:sp>
+        <p:nvSpPr>
+          <p:cNvPr id="21" name="Rectangle 20"/>
+          <p:cNvSpPr/>
+          <p:nvPr/>
+        </p:nvSpPr>
+        <p:spPr>
+          <a:xfrm>
+            <a:off x="365760" y="5852160"/>
+            <a:ext cx="7498079" cy="411480"/>
+          </a:xfrm>
+          <a:prstGeom prst="rect">
+            <a:avLst/>
+          </a:prstGeom>
+          <a:solidFill>
+            <a:srgbClr val="9FB88D"/>
+          </a:solidFill>
+          <a:ln>
+            <a:noFill/>
+          </a:ln>
+        </p:spPr>
+        <p:style>
+          <a:lnRef idx="1">
+            <a:schemeClr val="accent1"/>
+          </a:lnRef>
+          <a:fillRef idx="3">
+            <a:schemeClr val="accent1"/>
+          </a:fillRef>
+          <a:effectRef idx="2">
+            <a:schemeClr val="accent1"/>
+          </a:effectRef>
+          <a:fontRef idx="minor">
+            <a:schemeClr val="lt1"/>
+          </a:fontRef>
+        </p:style>
+        <p:txBody>
+          <a:bodyPr rtlCol="0" anchor="ctr"/>
+          <a:lstStyle/>
+          <a:p>
+            <a:pPr algn="ctr"/>
+          </a:p>
+        </p:txBody>
+      </p:sp>
+      <p:sp>
+        <p:nvSpPr>
+          <p:cNvPr id="22" name="TextBox 21"/>
+          <p:cNvSpPr txBox="1"/>
+          <p:nvPr/>
+        </p:nvSpPr>
+        <p:spPr>
+          <a:xfrm>
+            <a:off x="4114800" y="5925312"/>
+            <a:ext cx="3108960" cy="274320"/>
+          </a:xfrm>
+          <a:prstGeom prst="rect">
+            <a:avLst/>
+          </a:prstGeom>
+          <a:noFill/>
+        </p:spPr>
+        <p:txBody>
+          <a:bodyPr wrap="square">
+            <a:spAutoFit/>
+          </a:bodyPr>
+          <a:lstStyle/>
+          <a:p>
+            <a:pPr algn="r"/>
+            <a:r>
+              <a:rPr sz="950" b="1" i="0">
+                <a:solidFill>
+                  <a:srgbClr val="243B31"/>
+                </a:solidFill>
+                <a:latin typeface="Calibri"/>
+              </a:rPr>
+              <a:t>[certificate.issued_on: 2026-10-11]</a:t>
+            </a:r>
+          </a:p>
+        </p:txBody>
+      </p:sp>
+      <p:sp>
+        <p:nvSpPr>
+          <p:cNvPr id="23" name="Rectangle 22"/>
+          <p:cNvSpPr/>
+          <p:nvPr/>
+        </p:nvSpPr>
+        <p:spPr>
+          <a:xfrm>
+            <a:off x="7315200" y="5852160"/>
+            <a:ext cx="548640" cy="411480"/>
+          </a:xfrm>
+          <a:prstGeom prst="rect">
+            <a:avLst/>
+          </a:prstGeom>
+          <a:solidFill>
+            <a:srgbClr val="243B31"/>
+          </a:solidFill>
+          <a:ln>
+            <a:noFill/>
+          </a:ln>
+        </p:spPr>
+        <p:style>
+          <a:lnRef idx="1">
+            <a:schemeClr val="accent1"/>
+          </a:lnRef>
+          <a:fillRef idx="3">
+            <a:schemeClr val="accent1"/>
+          </a:fillRef>
+          <a:effectRef idx="2">
+            <a:schemeClr val="accent1"/>
+          </a:effectRef>
+          <a:fontRef idx="minor">
+            <a:schemeClr val="lt1"/>
+          </a:fontRef>
+        </p:style>
+        <p:txBody>
+          <a:bodyPr rtlCol="0" anchor="ctr"/>
+          <a:lstStyle/>
+          <a:p>
+            <a:pPr algn="ctr"/>
+          </a:p>
+        </p:txBody>
+      </p:sp>
+      <p:sp>
+        <p:nvSpPr>
+          <p:cNvPr id="24" name="Rectangle 23"/>
           <p:cNvSpPr/>
           <p:nvPr/>
         </p:nvSpPr>
@@ -14243,7 +14457,7 @@
       </p:sp>
       <p:sp>
         <p:nvSpPr>
-          <p:cNvPr id="20" name="TextBox 19"/>
+          <p:cNvPr id="25" name="TextBox 24"/>
           <p:cNvSpPr txBox="1"/>
           <p:nvPr/>
         </p:nvSpPr>
@@ -14265,13 +14479,13 @@
           <a:p>
             <a:pPr algn="l"/>
             <a:r>
-              <a:rPr sz="1500" b="1">
+              <a:rPr sz="1450" b="1">
                 <a:solidFill>
                   <a:srgbClr val="CFE870"/>
                 </a:solidFill>
                 <a:latin typeface="Calibri"/>
               </a:rPr>
-              <a:t>How It Works</a:t>
+              <a:t>Certificate Features</a:t>
             </a:r>
           </a:p>
           <a:p>
@@ -14281,13 +14495,13 @@
               </a:spcBef>
             </a:pPr>
             <a:r>
-              <a:rPr sz="1400">
+              <a:rPr sz="1350">
                 <a:solidFill>
                   <a:srgbClr val="FFFEFA"/>
                 </a:solidFill>
                 <a:latin typeface="Calibri"/>
               </a:rPr>
-              <a:t>• ✅  Student name pulled from verified account</a:t>
+              <a:t>• ✅  Designed with official distributor layout</a:t>
             </a:r>
           </a:p>
           <a:p>
@@ -14297,13 +14511,13 @@
               </a:spcBef>
             </a:pPr>
             <a:r>
-              <a:rPr sz="1400">
+              <a:rPr sz="1350">
                 <a:solidFill>
                   <a:srgbClr val="FFFEFA"/>
                 </a:solidFill>
                 <a:latin typeface="Calibri"/>
               </a:rPr>
-              <a:t>• ✅  Event title &amp; date auto-populated</a:t>
+              <a:t>• ✅  Adaptive layout fits perfectly on mobile screens</a:t>
             </a:r>
           </a:p>
           <a:p>
@@ -14313,13 +14527,13 @@
               </a:spcBef>
             </a:pPr>
             <a:r>
-              <a:rPr sz="1400">
+              <a:rPr sz="1350">
                 <a:solidFill>
                   <a:srgbClr val="FFFEFA"/>
                 </a:solidFill>
                 <a:latin typeface="Calibri"/>
               </a:rPr>
-              <a:t>• ✅  Admin signature embedded via CSS blend</a:t>
+              <a:t>• ✅  Digital authentication seal &amp; QR verification</a:t>
             </a:r>
           </a:p>
           <a:p>
@@ -14329,13 +14543,13 @@
               </a:spcBef>
             </a:pPr>
             <a:r>
-              <a:rPr sz="1400">
+              <a:rPr sz="1350">
                 <a:solidFill>
                   <a:srgbClr val="FFFEFA"/>
                 </a:solidFill>
                 <a:latin typeface="Calibri"/>
               </a:rPr>
-              <a:t>• ✅  One-click Print → save as PDF</a:t>
+              <a:t>• ✅  Admin signature integrated via CSS blend</a:t>
             </a:r>
           </a:p>
           <a:p>
@@ -14345,13 +14559,13 @@
               </a:spcBef>
             </a:pPr>
             <a:r>
-              <a:rPr sz="1400">
+              <a:rPr sz="1350">
                 <a:solidFill>
                   <a:srgbClr val="FFFEFA"/>
                 </a:solidFill>
                 <a:latin typeface="Calibri"/>
               </a:rPr>
-              <a:t>• ✅  Works for every registered event</a:t>
+              <a:t>• ✅  Landscape A4 auto-print ready (@page size)</a:t>
             </a:r>
           </a:p>
         </p:txBody>

</xml_diff>